<commit_message>
v7.3 presentation PPTX re-exported with the new title
Co-Authored-By: Claude Opus 5.5 <noreply@anthropic.com>
</commit_message>
<xml_diff>
--- a/results/repair_v7_3/presentation/v7.3_발표자료.pptx
+++ b/results/repair_v7_3/presentation/v7.3_발표자료.pptx
@@ -2415,7 +2415,7 @@
         <p:spPr>
           <a:xfrm>
             <a:off x="853901" y="2450753"/>
-            <a:ext cx="10798723" cy="1366441"/>
+            <a:ext cx="10798723" cy="1310580"/>
           </a:xfrm>
           <a:prstGeom prst="rect">
             <a:avLst/>
@@ -2431,12 +2431,12 @@
           <a:p>
             <a:pPr algn="l" indent="0" marL="0">
               <a:lnSpc>
-                <a:spcPts val="5280"/>
+                <a:spcPts val="5060"/>
               </a:lnSpc>
               <a:buNone/>
             </a:pPr>
             <a:r>
-              <a:rPr lang="en-US" sz="4800" b="1" i="0" dirty="0">
+              <a:rPr lang="en-US" sz="4400" b="1" i="0" dirty="0">
                 <a:solidFill>
                   <a:srgbClr val="F2EFE8"/>
                 </a:solidFill>
@@ -2444,9 +2444,29 @@
                 <a:ea typeface="IBM Plex Sans KR" pitchFamily="34" charset="-122"/>
                 <a:cs typeface="IBM Plex Sans KR" pitchFamily="34" charset="-120"/>
               </a:rPr>
-              <a:t>분해 경험을 SKILL.md로 저장하고 재사용하는 LLM 기반 Disassembly Planner</a:t>
-            </a:r>
-            <a:endParaRPr lang="en-US" sz="4800" dirty="0"/>
+              <a:t>SKILL.md와 Procedural Memory를 통한</a:t>
+            </a:r>
+            <a:endParaRPr lang="en-US" sz="4400" dirty="0"/>
+          </a:p>
+          <a:p>
+            <a:pPr algn="l" indent="0" marL="0">
+              <a:lnSpc>
+                <a:spcPts val="5060"/>
+              </a:lnSpc>
+              <a:buNone/>
+            </a:pPr>
+            <a:r>
+              <a:rPr lang="en-US" sz="4400" b="1" i="0" dirty="0">
+                <a:solidFill>
+                  <a:srgbClr val="F2EFE8"/>
+                </a:solidFill>
+                <a:latin typeface="IBM Plex Sans KR" pitchFamily="34" charset="0"/>
+                <a:ea typeface="IBM Plex Sans KR" pitchFamily="34" charset="-122"/>
+                <a:cs typeface="IBM Plex Sans KR" pitchFamily="34" charset="-120"/>
+              </a:rPr>
+              <a:t>LLM 기반 Disassembly Planner</a:t>
+            </a:r>
+            <a:endParaRPr lang="en-US" sz="4400" dirty="0"/>
           </a:p>
         </p:txBody>
       </p:sp>
@@ -21253,9 +21273,9 @@
 </file>
 
 <file path=ppt/theme/theme1.xml><?xml version="1.0" encoding="utf-8"?>
-<a:theme xmlns:a="http://schemas.openxmlformats.org/drawingml/2006/main" name="실패에서 배우는 분해 계획">
+<a:theme xmlns:a="http://schemas.openxmlformats.org/drawingml/2006/main" name="SKILL.md와 Procedural Memory를 통한 LLM 기반 Disassembly Planner">
   <a:themeElements>
-    <a:clrScheme name="실패에서 배우는 분해 계획">
+    <a:clrScheme name="SKILL.md와 Procedural Memory를 통한 LLM 기반 Disassembly Planner">
       <a:dk1>
         <a:srgbClr val="1C2430"/>
       </a:dk1>
@@ -21293,7 +21313,7 @@
         <a:srgbClr val="954F72"/>
       </a:folHlink>
     </a:clrScheme>
-    <a:fontScheme name="실패에서 배우는 분해 계획">
+    <a:fontScheme name="SKILL.md와 Procedural Memory를 통한 LLM 기반 Disassembly Planner">
       <a:majorFont>
         <a:latin typeface="IBM Plex Sans KR"/>
         <a:ea typeface=""/>

</xml_diff>

<commit_message>
v7.3 presentation revised after blind review: competition cover with CAD renders, 24/24 framed as recorded-path reuse, softened claims, cost slide, limits row (PPTX + slide sources)
Co-Authored-By: Claude Opus 5.5 <noreply@anthropic.com>
</commit_message>
<xml_diff>
--- a/results/repair_v7_3/presentation/v7.3_발표자료.pptx
+++ b/results/repair_v7_3/presentation/v7.3_발표자료.pptx
@@ -523,7 +523,7 @@
           <a:p>
             <a:r>
               <a:rPr lang="en-US" dirty="0"/>
-              <a:t>안녕하세요. 이 발표는 LLM이 CAD 조립체의 분해 순서를 계획할 때, 실패에서 배운 해결 절차를 SKILL.md라는 문서로 저장하고 다음 분해에 재사용하면 더 잘하게 되는지를 다룹니다. 모델의 가중치는 바꾸지 않고, 사람이 읽을 수 있는 문서만으로 경험을 쌓는 방식입니다.</a:t>
+              <a:t>안녕하세요. 이 발표는 LLM이 CAD 조립체의 분해 순서를 계획할 때, 실패에서 배운 해결 절차를 SKILL.md라는 문서로 저장하고 다음 분해에 재사용하면 더 잘하게 되는지를 다룹니다. 모델의 가중치는 바꾸지 않고, 사람이 읽을 수 있는 문서만으로 경험을 쌓는 방식입니다. 아래 그림은 평가에 쓴, 한 번도 쓰지 않았던 ASAP CAD 네 개를 시뮬레이션 시작 상태로 그린 것입니다.</a:t>
             </a:r>
             <a:endParaRPr lang="en-US" dirty="0"/>
           </a:p>
@@ -787,7 +787,7 @@
           <a:p>
             <a:r>
               <a:rPr lang="en-US" dirty="0"/>
-              <a:t>이번 결과에서 알 수 있는 점은 네 가지입니다. 첫째, 같은 조립체에 대한 조립체별 SKILL.md는 바로 효과가 있었습니다. frontier 모델이 아닌 reasoning low 설정의 gpt-6-luna에서도 24번 모두 성공했습니다. 다만 모델 크기를 바꿔 비교하지는 않았으므로, 이 모델 설정에서의 결과입니다. 둘째, 처음 보는 조립체에 쓰는 범용 SKILL.md는 고정된 규칙이 아니라, 가정이 맞는지 먼저 확인하는 조건부 형태여야 합니다. 셋째, 탐색은 고정 알고리즘이 맡고 LLM은 순위 판단만 하는 C 구조가 S5와 S3 어느 쪽에서도 처음 보는 조립체 네 개를 모두 분해해 가장 안정적이었지만, 토큰 비용이 큽니다. 넷째, 미리 규칙을 고정하고, 재실행하지 않고, 기록을 재생해 확인하는 장치 덕분에 결과를 원하는 쪽으로 맞추지 않았습니다. 승인되지 않은 S5도 결과 그대로 보고했습니다.</a:t>
+              <a:t>이번 결과에서 알 수 있는 점은 네 가지입니다. 첫째, 검증된 제거 순서를 조립체별 SKILL.md로 남기면 같은 조립체는 다시 분해할 때 그대로 재현됐습니다. reasoning low 설정의 gpt-6-luna에서 24번 모두 성공했고, 주된 원인은 기록된 순서의 재사용입니다. 모델 크기를 바꿔 비교하지는 않았으므로 이 모델 설정에서의 결과입니다. 둘째, 처음 보는 조립체에 쓰는 범용 SKILL.md는 고정된 규칙이 아니라, 가정이 맞는지 먼저 확인하는 조건부 형태여야 합니다. 셋째, 탐색은 고정 알고리즘이 맡고 LLM은 순위 판단만 하는 C 구조가 S5와 S3 어느 쪽에서도 처음 보는 조립체 네 개를 모두 분해했습니다. 다만 A와 B보다 CAD 하나를 더 푼 차이라 크다고 말하기는 어렵고, 토큰 비용이 큽니다. 넷째, 미리 규칙을 고정하고, 재실행하지 않고, 기록을 재생해 확인하는 장치 덕분에 결과를 원하는 쪽으로 맞추지 않았습니다. 승인되지 않은 S5도 결과 그대로 보고했습니다.</a:t>
             </a:r>
             <a:endParaRPr lang="en-US" dirty="0"/>
           </a:p>
@@ -875,7 +875,7 @@
           <a:p>
             <a:r>
               <a:rPr lang="en-US" dirty="0"/>
-              <a:t>현장 적용은 실험으로 검증한 내용이 아니라 제안입니다. 가장 직접적인 곳은 같은 제품군이 반복해서 들어오는 재제조나 정비 라인입니다. 조립체별 SKILL.md를 쌓아 두면 두 번째부터는 최소 시도로 분해 순서를 제시할 수 있습니다. 또 SKILL.md는 사람이 읽고 고치고 승인할 수 있는 파일이므로 작업 표준서나 안전 규칙과 함께 관리할 수 있습니다. 설계 단계에서는 시뮬레이션으로 분해 가능성과 막히는 부품을 먼저 확인할 수 있고, 조립체별 SKILL.md가 쌓이면 여러 제품에 공통인 패턴만 검증을 거쳐 범용 SKILL.md로 정리할 수 있습니다. 실제 로봇 제어나 힘 기반 분해는 이번 연구 범위 밖입니다.</a:t>
+              <a:t>이 결과를 산업 현장의 비용으로 보면 이렇습니다. 같은 제품을 두 번째로 분해할 때, 조립체별 SKILL.md가 없으면 B는 평균 18번, C는 약 44번의 실패한 제거 시도를 했고, 각각 네 번 중 한 번은 15분 안에 끝내지 못했습니다. 조립체별 SKILL.md가 있으면 실패한 시도는 거의 0이고, 평균 시간은 137초로 줄었으며, 24번 모두 성공했습니다. 이 SKILL.md를 만드는 데 드는 비용은 모델 호출 한 번, 약 1.6만 토큰이고 물리 시도는 들지 않습니다. 재료인 1차 기록은 원래 하던 분해에서 나옵니다. 그래서 실패 시도와 시간은 첫 재방문부터 이득이고, 토큰은 C는 회당 약 3.1만이 줄어 첫 재방문에 회수되지만 B는 거의 같습니다. 반복 입고 제품이 많은 재제조나 정비 라인이 가장 직접적인 적용처이고, SKILL.md는 사람이 검수할 수 있는 파일이라는 장점도 있습니다. 다만 현장 적용은 실험으로 검증하지 않은 제안이고, 모델 단가를 확인하지 못해 금액으로는 환산하지 않았습니다.</a:t>
             </a:r>
             <a:endParaRPr lang="en-US" dirty="0"/>
           </a:p>
@@ -963,7 +963,7 @@
           <a:p>
             <a:r>
               <a:rPr lang="en-US" dirty="0"/>
-              <a:t>한계도 분명합니다. 물리는 여섯 방향 직선 제거만 다루고, 로봇이나 그리퍼, 힘 기반 분해는 포함하지 않습니다. 이 물리 모델에서 완전 분해가 가능한 새 CAD가 드물어서, 후보 92개 중 4개만 평가에 쓸 수 있었고 표본이 작습니다. 새 범용 SKILL.md S5는 개발 검증을 통과하지 못했고, 고정 규칙의 예외를 놓쳤습니다. 모든 평가 CAD에 1차 성공이 있었기 때문에, 실패 기록만으로 만든 조립체별 SKILL.md의 효과는 시험하지 못했습니다. 모델은 gpt-6-luna 하나만 썼고 모델 크기를 바꿔 비교하지 않았으므로, ASPIRE가 남긴 약한 모델에 대한 질문에는 부분적으로만 답합니다. 느린 CAD에서는 시간 예산이 결과를 좌우했습니다. 또 B는 LLM이 쓴 탐색 코드가 런타임에 거부되거나, 같은 제거와 복원을 반복하는 루프에 빠져 실패하기도 했습니다. 마지막으로 SKILL.md가 없는 A조차 같은 CAD에서 검사 9회에서 54회까지 흔들렸기 때문에, 조건 간 작은 차이는 조심해서 해석해야 합니다.</a:t>
+              <a:t>한계도 분명합니다. 물리는 여섯 방향 직선 제거만 다루고, 로봇이나 그리퍼, 힘 기반 분해는 포함하지 않습니다. 이 물리 모델에서 완전 분해가 가능한 새 CAD가 드물어서, 후보 92개 중 4개만 평가에 쓸 수 있었고 표본이 작습니다. 새 범용 SKILL.md S5는 개발 검증을 통과하지 못했고, 고정 규칙의 예외를 놓쳤습니다. 또 같은 조립체 2차 시도의 성공이 LLM 없이 기록된 경로만 재생해도 나오는지는 확인하지 않았습니다. 모든 평가 CAD에 1차 성공이 있었기 때문에, 실패 기록만으로 만든 조립체별 SKILL.md의 효과는 시험하지 못했습니다. 모델은 gpt-6-luna 하나만 썼고 모델 크기를 바꿔 비교하지 않았으므로, ASPIRE가 남긴 약한 모델에 대한 질문에는 부분적으로만 답합니다. 느린 CAD에서는 시간 예산이 결과를 좌우했습니다. 또 B는 LLM이 쓴 탐색 코드가 런타임에 거부되거나, 같은 제거와 복원을 반복하는 루프에 빠져 실패하기도 했습니다. 마지막으로 SKILL.md가 없는 A조차 같은 CAD에서 검사 9회에서 54회까지 흔들렸기 때문에, 조건 간 작은 차이는 조심해서 해석해야 합니다.</a:t>
             </a:r>
             <a:endParaRPr lang="en-US" dirty="0"/>
           </a:p>
@@ -1051,7 +1051,7 @@
           <a:p>
             <a:r>
               <a:rPr lang="en-US" dirty="0"/>
-              <a:t>결론입니다. 처음에 ASPIRE가 남긴 질문, 즉 frontier 모델이 아닌 더 약한 모델에서도 경험을 저장하고 재사용하는 방식이 통하는가에 대해, reasoning low 설정의 gpt-6-luna에서 조립체별 SKILL.md가 있으면 같은 조립체는 최소 시도로 분해할 수 있었습니다. 새 CAD 네 개에서 24번 모두 성공했습니다. 반면 처음 보는 조립체로의 일반화는 아직 약하고, 고정 규칙보다 가정을 먼저 확인하는 조건부 범용 SKILL.md와 사전 검증이 필요합니다. 다음 단계는 세 가지입니다. 실패 기록만으로 만든 조립체별 SKILL.md가 도움이 되는지 확인하고, 예외 조건을 갖춘 범용 SKILL.md와 더 강한 규칙 검사를 만들고, 더 많은 CAD와 반복, 그리고 모델 크기 비교로 통계적으로 검증하는 것입니다. 감사합니다.</a:t>
+              <a:t>결론입니다. 처음에 ASPIRE가 남긴 질문, 즉 frontier 모델이 아닌 설정에서도 경험을 저장하고 재사용하는 방식이 통하는가에 대해, reasoning low 설정의 gpt-6-luna에서 조립체별 SKILL.md에 기록된 순서로 같은 조립체는 최소 시도로 분해할 수 있었습니다. 새 CAD 네 개에서 24번 모두 성공했고, 주된 원인은 검증된 순서의 재사용입니다. 모델 크기 비교는 하지 않았습니다. 반면 처음 보는 조립체로의 일반화는 아직 약하고, 고정 규칙보다 가정을 먼저 확인하는 조건부 범용 SKILL.md와 사전 검증이 필요합니다. 다음 단계는 세 가지입니다. 실패 기록만으로 만든 조립체별 SKILL.md가 도움이 되는지 확인하고, 예외 조건을 갖춘 범용 SKILL.md와 더 강한 규칙 검사를 만들고, 더 많은 CAD와 반복, 그리고 모델 크기 비교로 통계적으로 검증하는 것입니다. 감사합니다.</a:t>
             </a:r>
             <a:endParaRPr lang="en-US" dirty="0"/>
           </a:p>
@@ -1315,7 +1315,7 @@
           <a:p>
             <a:r>
               <a:rPr lang="en-US" dirty="0"/>
-              <a:t>Disassembly planner는 CAD 조립체를 입력으로 받아 어떤 부품을 어느 방향으로 어떤 순서로 뺄지 정합니다. 행동은 부품 하나와 여섯 개 방향 라벨 중 하나입니다. 행동마다 두 단계로 판정합니다. 먼저 원본 메시로 빼는 경로가 다른 부품과 겹치는지 보고, 통과하면 남은 부품을 MuJoCo로 1.5초 시뮬레이션해서 무너지지 않는지 확인합니다. 어려운 점은 막힘이 상태에 따라 바뀐다는 것, 그리고 검사가 비싸다는 것입니다. 충돌로 거절되는 검사는 중앙값 2초, 불안정 판정은 약 20초가 걸리고, 에피소드당 검사 240회와 900초라는 예산이 있습니다.</a:t>
+              <a:t>오른쪽 그림은 평가에 쓴 CAD 02260입니다. 부품 열한 개 중 하나가 바닥에 고정되어 있고, 나머지 열 개를 모두 빼면 성공입니다. Disassembly planner는 CAD 조립체를 입력으로 받아 어떤 부품을 어느 방향으로 어떤 순서로 뺄지 정합니다. 행동은 부품 하나와 여섯 개 방향 라벨 중 하나입니다. 행동마다 두 단계로 판정합니다. 먼저 원본 메시로 빼는 경로가 다른 부품과 겹치는지 보고, 통과하면 남은 부품을 MuJoCo로 1.5초 시뮬레이션해서 무너지지 않는지 확인합니다. 어려운 점은 막힘이 상태에 따라 바뀐다는 것, 그리고 검사가 비싸다는 것입니다. 충돌로 거절되는 검사는 중앙값 2초, 불안정 판정은 약 20초가 걸리고, 에피소드당 검사 240회와 900초라는 예산이 있습니다.</a:t>
             </a:r>
             <a:endParaRPr lang="en-US" dirty="0"/>
           </a:p>
@@ -1403,7 +1403,7 @@
           <a:p>
             <a:r>
               <a:rPr lang="en-US" dirty="0"/>
-              <a:t>A, B, C 세 구조를 둔 이유는 두 가지 효과를 따로 재기 위해서입니다. A는 SKILL.md 없이 LLM이 Python 탐색 코드를 직접 쓰는 기준선입니다. B는 같은 방식이지만 SKILL.md를 먼저 읽고 코드에 반영합니다. C는 탐색 자체를 host의 고정 깊이 우선 탐색이 맡고, LLM은 후보 동작의 순위만 정하며, SKILL.md는 그 순위 판단에 참고합니다. 그래서 A와 B를 비교하면 SKILL.md의 효과를, B와 C를 비교하면 LLM에게 탐색까지 맡길 때와 순위 판단만 맡길 때의 차이, 즉 역할 분담의 효과를 볼 수 있습니다. 세 구조 모두 같은 모델, 같은 API, 같은 예산을 쓰기 때문에 차이는 이 두 가지에서만 나옵니다.</a:t>
+              <a:t>A, B, C 세 구조를 둔 이유는 두 가지 효과를 따로 재기 위해서입니다. A는 SKILL.md 없이 LLM이 Python 탐색 코드를 직접 쓰는 기준선입니다. B는 같은 방식이지만 SKILL.md를 먼저 읽고 코드에 반영합니다. C는 탐색 자체를 host의 고정 깊이 우선 탐색이 맡고, LLM은 후보 동작의 순위만 정하며, SKILL.md는 그 순위 판단에 참고합니다. 그래서 A와 B를 비교하면 SKILL.md의 효과를, B와 C를 비교하면 LLM에게 탐색까지 맡길 때와 순위 판단만 맡길 때의 차이, 즉 역할 분담의 효과를 볼 수 있습니다. 세 구조 모두 같은 모델, 같은 API, 같은 예산을 쓰므로 설계상 다른 점은 이 두 가지뿐입니다. 다만 같은 조건에서도 결과가 흔들리기 때문에, 작은 차이는 조심해서 해석해야 합니다.</a:t>
             </a:r>
             <a:endParaRPr lang="en-US" dirty="0"/>
           </a:p>
@@ -1755,7 +1755,7 @@
           <a:p>
             <a:r>
               <a:rPr lang="en-US" dirty="0"/>
-              <a:t>첫 번째 결과는 같은 조립체를 다시 분해할 때입니다. 표는 최신 S5 분기를 같은 CAD의 1차와 2차로 나란히 놓은 것입니다. SKILL.md가 없는 A는 2차에도 결과가 들쭉날쭉해서, 05879는 17회에서 50회로 늘고 03937은 54회에서 9회로 줄었으며 02260은 두 번 다 시간 초과였습니다. 반면 1차 기록으로 만든 조립체별 SKILL.md를 받은 B와 C는 네 CAD 모두 2차에서 검사 수가 제거할 부품 수와 정확히 같았습니다. 즉 한 번도 틀리지 않고 바로 분해했습니다. 이전 버전 S3 분기에서도 B와 C를 두 번씩 돌려 16번 모두 성공했고 15번이 최소 검사였습니다. 그래서 조립체별 SKILL.md를 쓴 2차 시도는 모두 24번 성공했습니다. 조립체별 SKILL.md가 없는 2차 시도는 12번 중 9번 성공이었습니다. 차이가 가장 큰 곳은 가장 느린 02260으로, 조립체별 SKILL.md를 쓰면 약 7분에 끝났지만 없으면 15분 안에 끝내지 못한 경우가 있었습니다.</a:t>
+              <a:t>첫 번째 결과는 같은 조립체를 다시 분해할 때입니다. 표는 최신 S5 분기를 같은 CAD의 1차와 2차로 나란히 놓은 것입니다. SKILL.md가 없는 A는 2차에도 결과가 들쭉날쭉해서, 05879는 17회에서 50회로 늘고 03937은 54회에서 9회로 줄었으며 02260은 두 번 다 시간 초과였습니다. 반면 1차 기록으로 만든 조립체별 SKILL.md를 받은 B와 C는 네 CAD 모두 2차에서 검사 수가 제거할 부품 수와 정확히 같았습니다. 즉 한 번도 틀리지 않고 바로 분해했습니다. 이전 버전 S3 분기에서도 B와 C를 두 번씩 돌려 16번 모두 성공했고 15번이 최소 검사였습니다. 그래서 조립체별 SKILL.md를 쓴 2차 시도는 모두 24번 성공했습니다. 조립체별 SKILL.md가 없는 2차 시도는 12번 중 9번 성공이었습니다. 다만 이 결과를 정직하게 읽어야 합니다. 조립체별 SKILL.md에는 1차에서 검증된 제거 순서가 그대로 붙어 있으므로, 2차 성공의 주된 원인은 그 기록을 다시 쓴 것입니다. LLM 없이 경로만 재생하는 대조는 하지 않았습니다. 그래서 이 결과가 말하는 것은, 검증된 경로를 SKILL.md로 남기면 LLM planner가 그것을 그대로 따라 같은 제품을 실패 없이 다시 분해한다는 것이고, 의미는 같은 제품이 반복해서 들어오는 현장에서의 신뢰성과 실패 시도 감소에 있습니다.</a:t>
             </a:r>
             <a:endParaRPr lang="en-US" dirty="0"/>
           </a:p>
@@ -2398,7 +2398,7 @@
                 <a:ea typeface="IBM Plex Sans KR" pitchFamily="34" charset="-122"/>
                 <a:cs typeface="IBM Plex Sans KR" pitchFamily="34" charset="-120"/>
               </a:rPr>
-              <a:t>독립심화학습 연구 발표</a:t>
+              <a:t>제22회 한국대학생 산업공학 프로젝트경진대회</a:t>
             </a:r>
             <a:endParaRPr lang="en-US" sz="1400" dirty="0"/>
           </a:p>
@@ -2414,7 +2414,7 @@
         </p:nvSpPr>
         <p:spPr>
           <a:xfrm>
-            <a:off x="853901" y="2450753"/>
+            <a:off x="853901" y="1905000"/>
             <a:ext cx="10798723" cy="1310580"/>
           </a:xfrm>
           <a:prstGeom prst="rect">
@@ -2470,6 +2470,29 @@
           </a:p>
         </p:txBody>
       </p:sp>
+      <p:pic>
+        <p:nvPicPr>
+          <p:cNvPr id="4" name="Image 0" descr="평가에 쓴 새 ASAP CAD 4개: 02260, 02991, 05879, 03937">    </p:cNvPr>
+          <p:cNvPicPr>
+            <a:picLocks noChangeAspect="1"/>
+          </p:cNvPicPr>
+          <p:nvPr/>
+        </p:nvPicPr>
+        <p:blipFill>
+          <a:blip r:embed="rId1"/>
+          <a:srcRect l="0" r="0" t="-58" b="-58"/>
+          <a:stretch/>
+        </p:blipFill>
+        <p:spPr>
+          <a:xfrm>
+            <a:off x="812800" y="3746500"/>
+            <a:ext cx="10566400" cy="1581150"/>
+          </a:xfrm>
+          <a:prstGeom prst="rect">
+            <a:avLst/>
+          </a:prstGeom>
+        </p:spPr>
+      </p:pic>
     </p:spTree>
   </p:cSld>
   <p:clrMapOvr>
@@ -7538,7 +7561,7 @@
                 <a:ea typeface="IBM Plex Sans KR" pitchFamily="34" charset="-122"/>
                 <a:cs typeface="IBM Plex Sans KR" pitchFamily="34" charset="-120"/>
               </a:rPr>
-              <a:t>조립체별 SKILL.md는 바로 효과가 있다</a:t>
+              <a:t>검증된 경로를 남기면 같은 조립체는 재현된다</a:t>
             </a:r>
             <a:endParaRPr lang="en-US" sz="1600" dirty="0"/>
           </a:p>
@@ -7582,7 +7605,7 @@
                 <a:ea typeface="IBM Plex Sans KR" pitchFamily="34" charset="-122"/>
                 <a:cs typeface="IBM Plex Sans KR" pitchFamily="34" charset="-120"/>
               </a:rPr>
-              <a:t>reasoning low 설정의 gpt-6-luna에서도 같은 조립체 2차 시도 24/24 성공, 그중 23번은 실패 검사 0</a:t>
+              <a:t>gpt-6-luna(low) 설정에서 2차 시도 24/24 성공, 23번은 실패 검사 0. 주된 원인은 기록된 순서의 재사용</a:t>
             </a:r>
             <a:endParaRPr lang="en-US" sz="1200" dirty="0"/>
           </a:p>
@@ -7900,7 +7923,7 @@
                 <a:ea typeface="IBM Plex Sans KR" pitchFamily="34" charset="-122"/>
                 <a:cs typeface="IBM Plex Sans KR" pitchFamily="34" charset="-120"/>
               </a:rPr>
-              <a:t>C는 처음 보는 조립체 1차 시도에서 S5·S3 모두 4/4로 가장 안정적. 대신 토큰은 A의 4~5배</a:t>
+              <a:t>C는 처음 보는 조립체 1차에서 S5·S3 모두 4/4 (A·B는 3/4, CAD 1개 차이). 대신 토큰은 A의 4~5배</a:t>
             </a:r>
             <a:endParaRPr lang="en-US" sz="1200" dirty="0"/>
           </a:p>
@@ -8179,7 +8202,7 @@
                 <a:ea typeface="IBM Plex Sans KR" pitchFamily="34" charset="-122"/>
                 <a:cs typeface="IBM Plex Sans KR" pitchFamily="34" charset="-120"/>
               </a:rPr>
-              <a:t>12 · 현장 적용과 활용 방안 (제안)</a:t>
+              <a:t>12 · 현장 가치와 비용</a:t>
             </a:r>
             <a:endParaRPr lang="en-US" sz="1200" dirty="0"/>
           </a:p>
@@ -8225,94 +8248,1832 @@
                 <a:ea typeface="IBM Plex Sans KR" pitchFamily="34" charset="-122"/>
                 <a:cs typeface="IBM Plex Sans KR" pitchFamily="34" charset="-120"/>
               </a:rPr>
-              <a:t>반복되는 제품일수록 SKILL.md가 쌓인다</a:t>
+              <a:t>같은 제품이 다시 오면 실패 시도가 거의 사라진다</a:t>
             </a:r>
             <a:endParaRPr lang="en-US" sz="3200" dirty="0"/>
           </a:p>
         </p:txBody>
       </p:sp>
-      <p:sp>
-        <p:nvSpPr>
-          <p:cNvPr id="4" name="Shape 2"/>
+      <p:graphicFrame>
+        <p:nvGraphicFramePr>
+          <p:cNvPr id="4" name="Table 0"/>
+          <p:cNvGraphicFramePr>
+            <a:graphicFrameLocks noGrp="1"/>
+          </p:cNvGraphicFramePr>
+          <p:nvPr>
+            <p:extLst>
+              <p:ext uri="{D42A27DB-BD31-4B8C-83A1-F6EECF244321}">
+                <p14:modId xmlns:p14="http://schemas.microsoft.com/office/powerpoint/2010/main" val="1579011935"/>
+              </p:ext>
+            </p:extLst>
+          </p:nvPr>
+        </p:nvGraphicFramePr>
+        <p:xfrm>
+          <a:off x="825500" y="1785541"/>
+          <a:ext cx="6743700" cy="1876723"/>
+        </p:xfrm>
+        <a:graphic>
+          <a:graphicData uri="http://schemas.openxmlformats.org/drawingml/2006/table">
+            <a:tbl>
+              <a:tblPr/>
+              <a:tblGrid>
+                <a:gridCol w="1888236"/>
+                <a:gridCol w="1348740"/>
+                <a:gridCol w="1213866"/>
+                <a:gridCol w="1078992"/>
+                <a:gridCol w="1213866"/>
+              </a:tblGrid>
+              <a:tr h="546001">
+                <a:tc>
+                  <a:txBody>
+                    <a:bodyPr/>
+                    <a:lstStyle/>
+                    <a:p>
+                      <a:pPr indent="0" marL="0">
+                        <a:lnSpc>
+                          <a:spcPts val="1680"/>
+                        </a:lnSpc>
+                        <a:buNone/>
+                      </a:pPr>
+                      <a:r>
+                        <a:rPr lang="en-US" sz="1200" b="1" dirty="0">
+                          <a:solidFill>
+                            <a:srgbClr val="F2EFE8"/>
+                          </a:solidFill>
+                          <a:latin typeface="IBM Plex Sans KR" pitchFamily="34" charset="0"/>
+                          <a:ea typeface="IBM Plex Sans KR" pitchFamily="34" charset="-122"/>
+                          <a:cs typeface="IBM Plex Sans KR" pitchFamily="34" charset="-120"/>
+                        </a:rPr>
+                        <a:t>2차 시도 · 조립체별 SKILL.md</a:t>
+                      </a:r>
+                      <a:endParaRPr lang="en-US" sz="1200" dirty="0">
+                        <a:latin typeface="IBM Plex Sans KR" charset="0"/>
+                        <a:ea typeface="IBM Plex Sans KR" charset="0"/>
+                        <a:cs typeface="IBM Plex Sans KR" charset="0"/>
+                      </a:endParaRPr>
+                    </a:p>
+                  </a:txBody>
+                  <a:tcPr marL="53340" marR="53340" marT="53340" marB="53340" anchor="t">
+                    <a:lnL w="12700" cap="flat" cmpd="sng" algn="ctr">
+                      <a:solidFill>
+                        <a:srgbClr val="C4C4C0"/>
+                      </a:solidFill>
+                      <a:prstDash val="solid"/>
+                      <a:round/>
+                      <a:headEnd type="none" w="med" len="med"/>
+                      <a:tailEnd type="none" w="med" len="med"/>
+                    </a:lnL>
+                    <a:lnR w="12700" cap="flat" cmpd="sng" algn="ctr">
+                      <a:solidFill>
+                        <a:srgbClr val="1A202A"/>
+                      </a:solidFill>
+                      <a:prstDash val="solid"/>
+                      <a:round/>
+                      <a:headEnd type="none" w="med" len="med"/>
+                      <a:tailEnd type="none" w="med" len="med"/>
+                    </a:lnR>
+                    <a:lnT w="12700" cap="flat" cmpd="sng" algn="ctr">
+                      <a:solidFill>
+                        <a:srgbClr val="C4C4C0"/>
+                      </a:solidFill>
+                      <a:prstDash val="solid"/>
+                      <a:round/>
+                      <a:headEnd type="none" w="med" len="med"/>
+                      <a:tailEnd type="none" w="med" len="med"/>
+                    </a:lnT>
+                    <a:lnB w="12700" cap="flat" cmpd="sng" algn="ctr">
+                      <a:solidFill>
+                        <a:srgbClr val="1A202A"/>
+                      </a:solidFill>
+                      <a:prstDash val="solid"/>
+                      <a:round/>
+                      <a:headEnd type="none" w="med" len="med"/>
+                      <a:tailEnd type="none" w="med" len="med"/>
+                    </a:lnB>
+                    <a:solidFill>
+                      <a:srgbClr val="1C2430"/>
+                    </a:solidFill>
+                  </a:tcPr>
+                </a:tc>
+                <a:tc>
+                  <a:txBody>
+                    <a:bodyPr/>
+                    <a:lstStyle/>
+                    <a:p>
+                      <a:pPr algn="ctr" indent="0" marL="0">
+                        <a:lnSpc>
+                          <a:spcPts val="1680"/>
+                        </a:lnSpc>
+                        <a:buNone/>
+                      </a:pPr>
+                      <a:r>
+                        <a:rPr lang="en-US" sz="1200" b="1" dirty="0">
+                          <a:solidFill>
+                            <a:srgbClr val="F2EFE8"/>
+                          </a:solidFill>
+                          <a:latin typeface="IBM Plex Sans KR" pitchFamily="34" charset="0"/>
+                          <a:ea typeface="IBM Plex Sans KR" pitchFamily="34" charset="-122"/>
+                          <a:cs typeface="IBM Plex Sans KR" pitchFamily="34" charset="-120"/>
+                        </a:rPr>
+                        <a:t>실패한 제거 시도</a:t>
+                      </a:r>
+                      <a:endParaRPr lang="en-US" sz="1200" dirty="0">
+                        <a:latin typeface="IBM Plex Sans KR" charset="0"/>
+                        <a:ea typeface="IBM Plex Sans KR" charset="0"/>
+                        <a:cs typeface="IBM Plex Sans KR" charset="0"/>
+                      </a:endParaRPr>
+                    </a:p>
+                  </a:txBody>
+                  <a:tcPr marL="53340" marR="53340" marT="53340" marB="53340" anchor="t">
+                    <a:lnL w="12700" cap="flat" cmpd="sng" algn="ctr">
+                      <a:solidFill>
+                        <a:srgbClr val="1A202A"/>
+                      </a:solidFill>
+                      <a:prstDash val="solid"/>
+                      <a:round/>
+                      <a:headEnd type="none" w="med" len="med"/>
+                      <a:tailEnd type="none" w="med" len="med"/>
+                    </a:lnL>
+                    <a:lnR w="12700" cap="flat" cmpd="sng" algn="ctr">
+                      <a:solidFill>
+                        <a:srgbClr val="1A202A"/>
+                      </a:solidFill>
+                      <a:prstDash val="solid"/>
+                      <a:round/>
+                      <a:headEnd type="none" w="med" len="med"/>
+                      <a:tailEnd type="none" w="med" len="med"/>
+                    </a:lnR>
+                    <a:lnT w="12700" cap="flat" cmpd="sng" algn="ctr">
+                      <a:solidFill>
+                        <a:srgbClr val="C4C4C0"/>
+                      </a:solidFill>
+                      <a:prstDash val="solid"/>
+                      <a:round/>
+                      <a:headEnd type="none" w="med" len="med"/>
+                      <a:tailEnd type="none" w="med" len="med"/>
+                    </a:lnT>
+                    <a:lnB w="12700" cap="flat" cmpd="sng" algn="ctr">
+                      <a:solidFill>
+                        <a:srgbClr val="1A202A"/>
+                      </a:solidFill>
+                      <a:prstDash val="solid"/>
+                      <a:round/>
+                      <a:headEnd type="none" w="med" len="med"/>
+                      <a:tailEnd type="none" w="med" len="med"/>
+                    </a:lnB>
+                    <a:solidFill>
+                      <a:srgbClr val="1C2430"/>
+                    </a:solidFill>
+                  </a:tcPr>
+                </a:tc>
+                <a:tc>
+                  <a:txBody>
+                    <a:bodyPr/>
+                    <a:lstStyle/>
+                    <a:p>
+                      <a:pPr algn="ctr" indent="0" marL="0">
+                        <a:lnSpc>
+                          <a:spcPts val="1680"/>
+                        </a:lnSpc>
+                        <a:buNone/>
+                      </a:pPr>
+                      <a:r>
+                        <a:rPr lang="en-US" sz="1200" b="1" dirty="0">
+                          <a:solidFill>
+                            <a:srgbClr val="F2EFE8"/>
+                          </a:solidFill>
+                          <a:latin typeface="IBM Plex Sans KR" pitchFamily="34" charset="0"/>
+                          <a:ea typeface="IBM Plex Sans KR" pitchFamily="34" charset="-122"/>
+                          <a:cs typeface="IBM Plex Sans KR" pitchFamily="34" charset="-120"/>
+                        </a:rPr>
+                        <a:t>평균 시간</a:t>
+                      </a:r>
+                      <a:endParaRPr lang="en-US" sz="1200" dirty="0">
+                        <a:latin typeface="IBM Plex Sans KR" charset="0"/>
+                        <a:ea typeface="IBM Plex Sans KR" charset="0"/>
+                        <a:cs typeface="IBM Plex Sans KR" charset="0"/>
+                      </a:endParaRPr>
+                    </a:p>
+                  </a:txBody>
+                  <a:tcPr marL="53340" marR="53340" marT="53340" marB="53340" anchor="t">
+                    <a:lnL w="12700" cap="flat" cmpd="sng" algn="ctr">
+                      <a:solidFill>
+                        <a:srgbClr val="1A202A"/>
+                      </a:solidFill>
+                      <a:prstDash val="solid"/>
+                      <a:round/>
+                      <a:headEnd type="none" w="med" len="med"/>
+                      <a:tailEnd type="none" w="med" len="med"/>
+                    </a:lnL>
+                    <a:lnR w="12700" cap="flat" cmpd="sng" algn="ctr">
+                      <a:solidFill>
+                        <a:srgbClr val="1A202A"/>
+                      </a:solidFill>
+                      <a:prstDash val="solid"/>
+                      <a:round/>
+                      <a:headEnd type="none" w="med" len="med"/>
+                      <a:tailEnd type="none" w="med" len="med"/>
+                    </a:lnR>
+                    <a:lnT w="12700" cap="flat" cmpd="sng" algn="ctr">
+                      <a:solidFill>
+                        <a:srgbClr val="C4C4C0"/>
+                      </a:solidFill>
+                      <a:prstDash val="solid"/>
+                      <a:round/>
+                      <a:headEnd type="none" w="med" len="med"/>
+                      <a:tailEnd type="none" w="med" len="med"/>
+                    </a:lnT>
+                    <a:lnB w="12700" cap="flat" cmpd="sng" algn="ctr">
+                      <a:solidFill>
+                        <a:srgbClr val="1A202A"/>
+                      </a:solidFill>
+                      <a:prstDash val="solid"/>
+                      <a:round/>
+                      <a:headEnd type="none" w="med" len="med"/>
+                      <a:tailEnd type="none" w="med" len="med"/>
+                    </a:lnB>
+                    <a:solidFill>
+                      <a:srgbClr val="1C2430"/>
+                    </a:solidFill>
+                  </a:tcPr>
+                </a:tc>
+                <a:tc>
+                  <a:txBody>
+                    <a:bodyPr/>
+                    <a:lstStyle/>
+                    <a:p>
+                      <a:pPr algn="ctr" indent="0" marL="0">
+                        <a:lnSpc>
+                          <a:spcPts val="1680"/>
+                        </a:lnSpc>
+                        <a:buNone/>
+                      </a:pPr>
+                      <a:r>
+                        <a:rPr lang="en-US" sz="1200" b="1" dirty="0">
+                          <a:solidFill>
+                            <a:srgbClr val="F2EFE8"/>
+                          </a:solidFill>
+                          <a:latin typeface="IBM Plex Sans KR" pitchFamily="34" charset="0"/>
+                          <a:ea typeface="IBM Plex Sans KR" pitchFamily="34" charset="-122"/>
+                          <a:cs typeface="IBM Plex Sans KR" pitchFamily="34" charset="-120"/>
+                        </a:rPr>
+                        <a:t>성공</a:t>
+                      </a:r>
+                      <a:endParaRPr lang="en-US" sz="1200" dirty="0">
+                        <a:latin typeface="IBM Plex Sans KR" charset="0"/>
+                        <a:ea typeface="IBM Plex Sans KR" charset="0"/>
+                        <a:cs typeface="IBM Plex Sans KR" charset="0"/>
+                      </a:endParaRPr>
+                    </a:p>
+                  </a:txBody>
+                  <a:tcPr marL="53340" marR="53340" marT="53340" marB="53340" anchor="t">
+                    <a:lnL w="12700" cap="flat" cmpd="sng" algn="ctr">
+                      <a:solidFill>
+                        <a:srgbClr val="1A202A"/>
+                      </a:solidFill>
+                      <a:prstDash val="solid"/>
+                      <a:round/>
+                      <a:headEnd type="none" w="med" len="med"/>
+                      <a:tailEnd type="none" w="med" len="med"/>
+                    </a:lnL>
+                    <a:lnR w="12700" cap="flat" cmpd="sng" algn="ctr">
+                      <a:solidFill>
+                        <a:srgbClr val="1A202A"/>
+                      </a:solidFill>
+                      <a:prstDash val="solid"/>
+                      <a:round/>
+                      <a:headEnd type="none" w="med" len="med"/>
+                      <a:tailEnd type="none" w="med" len="med"/>
+                    </a:lnR>
+                    <a:lnT w="12700" cap="flat" cmpd="sng" algn="ctr">
+                      <a:solidFill>
+                        <a:srgbClr val="C4C4C0"/>
+                      </a:solidFill>
+                      <a:prstDash val="solid"/>
+                      <a:round/>
+                      <a:headEnd type="none" w="med" len="med"/>
+                      <a:tailEnd type="none" w="med" len="med"/>
+                    </a:lnT>
+                    <a:lnB w="12700" cap="flat" cmpd="sng" algn="ctr">
+                      <a:solidFill>
+                        <a:srgbClr val="1A202A"/>
+                      </a:solidFill>
+                      <a:prstDash val="solid"/>
+                      <a:round/>
+                      <a:headEnd type="none" w="med" len="med"/>
+                      <a:tailEnd type="none" w="med" len="med"/>
+                    </a:lnB>
+                    <a:solidFill>
+                      <a:srgbClr val="1C2430"/>
+                    </a:solidFill>
+                  </a:tcPr>
+                </a:tc>
+                <a:tc>
+                  <a:txBody>
+                    <a:bodyPr/>
+                    <a:lstStyle/>
+                    <a:p>
+                      <a:pPr algn="ctr" indent="0" marL="0">
+                        <a:lnSpc>
+                          <a:spcPts val="1680"/>
+                        </a:lnSpc>
+                        <a:buNone/>
+                      </a:pPr>
+                      <a:r>
+                        <a:rPr lang="en-US" sz="1200" b="1" dirty="0">
+                          <a:solidFill>
+                            <a:srgbClr val="F2EFE8"/>
+                          </a:solidFill>
+                          <a:latin typeface="IBM Plex Sans KR" pitchFamily="34" charset="0"/>
+                          <a:ea typeface="IBM Plex Sans KR" pitchFamily="34" charset="-122"/>
+                          <a:cs typeface="IBM Plex Sans KR" pitchFamily="34" charset="-120"/>
+                        </a:rPr>
+                        <a:t>토큰</a:t>
+                      </a:r>
+                      <a:endParaRPr lang="en-US" sz="1200" dirty="0">
+                        <a:latin typeface="IBM Plex Sans KR" charset="0"/>
+                        <a:ea typeface="IBM Plex Sans KR" charset="0"/>
+                        <a:cs typeface="IBM Plex Sans KR" charset="0"/>
+                      </a:endParaRPr>
+                    </a:p>
+                  </a:txBody>
+                  <a:tcPr marL="53340" marR="53340" marT="53340" marB="53340" anchor="t">
+                    <a:lnL w="12700" cap="flat" cmpd="sng" algn="ctr">
+                      <a:solidFill>
+                        <a:srgbClr val="1A202A"/>
+                      </a:solidFill>
+                      <a:prstDash val="solid"/>
+                      <a:round/>
+                      <a:headEnd type="none" w="med" len="med"/>
+                      <a:tailEnd type="none" w="med" len="med"/>
+                    </a:lnL>
+                    <a:lnR w="12700" cap="flat" cmpd="sng" algn="ctr">
+                      <a:solidFill>
+                        <a:srgbClr val="1A202A"/>
+                      </a:solidFill>
+                      <a:prstDash val="solid"/>
+                      <a:round/>
+                      <a:headEnd type="none" w="med" len="med"/>
+                      <a:tailEnd type="none" w="med" len="med"/>
+                    </a:lnR>
+                    <a:lnT w="12700" cap="flat" cmpd="sng" algn="ctr">
+                      <a:solidFill>
+                        <a:srgbClr val="C4C4C0"/>
+                      </a:solidFill>
+                      <a:prstDash val="solid"/>
+                      <a:round/>
+                      <a:headEnd type="none" w="med" len="med"/>
+                      <a:tailEnd type="none" w="med" len="med"/>
+                    </a:lnT>
+                    <a:lnB w="12700" cap="flat" cmpd="sng" algn="ctr">
+                      <a:solidFill>
+                        <a:srgbClr val="1A202A"/>
+                      </a:solidFill>
+                      <a:prstDash val="solid"/>
+                      <a:round/>
+                      <a:headEnd type="none" w="med" len="med"/>
+                      <a:tailEnd type="none" w="med" len="med"/>
+                    </a:lnB>
+                    <a:solidFill>
+                      <a:srgbClr val="1C2430"/>
+                    </a:solidFill>
+                  </a:tcPr>
+                </a:tc>
+              </a:tr>
+              <a:tr h="332680">
+                <a:tc>
+                  <a:txBody>
+                    <a:bodyPr/>
+                    <a:lstStyle/>
+                    <a:p>
+                      <a:pPr indent="0" marL="0">
+                        <a:lnSpc>
+                          <a:spcPts val="1680"/>
+                        </a:lnSpc>
+                        <a:buNone/>
+                      </a:pPr>
+                      <a:r>
+                        <a:rPr lang="en-US" sz="1200" dirty="0">
+                          <a:solidFill>
+                            <a:srgbClr val="3E4A57"/>
+                          </a:solidFill>
+                          <a:latin typeface="IBM Plex Sans KR" pitchFamily="34" charset="0"/>
+                          <a:ea typeface="IBM Plex Sans KR" pitchFamily="34" charset="-122"/>
+                          <a:cs typeface="IBM Plex Sans KR" pitchFamily="34" charset="-120"/>
+                        </a:rPr>
+                        <a:t>B 없음</a:t>
+                      </a:r>
+                      <a:endParaRPr lang="en-US" sz="1200" dirty="0">
+                        <a:latin typeface="IBM Plex Sans KR" charset="0"/>
+                        <a:ea typeface="IBM Plex Sans KR" charset="0"/>
+                        <a:cs typeface="IBM Plex Sans KR" charset="0"/>
+                      </a:endParaRPr>
+                    </a:p>
+                  </a:txBody>
+                  <a:tcPr marL="53340" marR="53340" marT="53340" marB="53340" anchor="t">
+                    <a:lnL w="12700" cap="flat" cmpd="sng" algn="ctr">
+                      <a:solidFill>
+                        <a:srgbClr val="C4C4C0"/>
+                      </a:solidFill>
+                      <a:prstDash val="solid"/>
+                      <a:round/>
+                      <a:headEnd type="none" w="med" len="med"/>
+                      <a:tailEnd type="none" w="med" len="med"/>
+                    </a:lnL>
+                    <a:lnR w="12700" cap="flat" cmpd="sng" algn="ctr">
+                      <a:solidFill>
+                        <a:srgbClr val="C4C4C0"/>
+                      </a:solidFill>
+                      <a:prstDash val="solid"/>
+                      <a:round/>
+                      <a:headEnd type="none" w="med" len="med"/>
+                      <a:tailEnd type="none" w="med" len="med"/>
+                    </a:lnR>
+                    <a:lnT w="12700" cap="flat" cmpd="sng" algn="ctr">
+                      <a:solidFill>
+                        <a:srgbClr val="1A202A"/>
+                      </a:solidFill>
+                      <a:prstDash val="solid"/>
+                      <a:round/>
+                      <a:headEnd type="none" w="med" len="med"/>
+                      <a:tailEnd type="none" w="med" len="med"/>
+                    </a:lnT>
+                    <a:lnB w="12700" cap="flat" cmpd="sng" algn="ctr">
+                      <a:solidFill>
+                        <a:srgbClr val="C4C4C0"/>
+                      </a:solidFill>
+                      <a:prstDash val="solid"/>
+                      <a:round/>
+                      <a:headEnd type="none" w="med" len="med"/>
+                      <a:tailEnd type="none" w="med" len="med"/>
+                    </a:lnB>
+                  </a:tcPr>
+                </a:tc>
+                <a:tc>
+                  <a:txBody>
+                    <a:bodyPr/>
+                    <a:lstStyle/>
+                    <a:p>
+                      <a:pPr algn="ctr" indent="0" marL="0">
+                        <a:lnSpc>
+                          <a:spcPts val="1680"/>
+                        </a:lnSpc>
+                        <a:buNone/>
+                      </a:pPr>
+                      <a:r>
+                        <a:rPr lang="en-US" sz="1200" dirty="0">
+                          <a:solidFill>
+                            <a:srgbClr val="3E4A57"/>
+                          </a:solidFill>
+                          <a:latin typeface="IBM Plex Sans KR" pitchFamily="34" charset="0"/>
+                          <a:ea typeface="IBM Plex Sans KR" pitchFamily="34" charset="-122"/>
+                          <a:cs typeface="IBM Plex Sans KR" pitchFamily="34" charset="-120"/>
+                        </a:rPr>
+                        <a:t>18</a:t>
+                      </a:r>
+                      <a:endParaRPr lang="en-US" sz="1200" dirty="0">
+                        <a:latin typeface="IBM Plex Sans KR" charset="0"/>
+                        <a:ea typeface="IBM Plex Sans KR" charset="0"/>
+                        <a:cs typeface="IBM Plex Sans KR" charset="0"/>
+                      </a:endParaRPr>
+                    </a:p>
+                  </a:txBody>
+                  <a:tcPr marL="53340" marR="53340" marT="53340" marB="53340" anchor="t">
+                    <a:lnL w="12700" cap="flat" cmpd="sng" algn="ctr">
+                      <a:solidFill>
+                        <a:srgbClr val="C4C4C0"/>
+                      </a:solidFill>
+                      <a:prstDash val="solid"/>
+                      <a:round/>
+                      <a:headEnd type="none" w="med" len="med"/>
+                      <a:tailEnd type="none" w="med" len="med"/>
+                    </a:lnL>
+                    <a:lnR w="12700" cap="flat" cmpd="sng" algn="ctr">
+                      <a:solidFill>
+                        <a:srgbClr val="C4C4C0"/>
+                      </a:solidFill>
+                      <a:prstDash val="solid"/>
+                      <a:round/>
+                      <a:headEnd type="none" w="med" len="med"/>
+                      <a:tailEnd type="none" w="med" len="med"/>
+                    </a:lnR>
+                    <a:lnT w="12700" cap="flat" cmpd="sng" algn="ctr">
+                      <a:solidFill>
+                        <a:srgbClr val="1A202A"/>
+                      </a:solidFill>
+                      <a:prstDash val="solid"/>
+                      <a:round/>
+                      <a:headEnd type="none" w="med" len="med"/>
+                      <a:tailEnd type="none" w="med" len="med"/>
+                    </a:lnT>
+                    <a:lnB w="12700" cap="flat" cmpd="sng" algn="ctr">
+                      <a:solidFill>
+                        <a:srgbClr val="C4C4C0"/>
+                      </a:solidFill>
+                      <a:prstDash val="solid"/>
+                      <a:round/>
+                      <a:headEnd type="none" w="med" len="med"/>
+                      <a:tailEnd type="none" w="med" len="med"/>
+                    </a:lnB>
+                  </a:tcPr>
+                </a:tc>
+                <a:tc>
+                  <a:txBody>
+                    <a:bodyPr/>
+                    <a:lstStyle/>
+                    <a:p>
+                      <a:pPr algn="ctr" indent="0" marL="0">
+                        <a:lnSpc>
+                          <a:spcPts val="1680"/>
+                        </a:lnSpc>
+                        <a:buNone/>
+                      </a:pPr>
+                      <a:r>
+                        <a:rPr lang="en-US" sz="1200" dirty="0">
+                          <a:solidFill>
+                            <a:srgbClr val="3E4A57"/>
+                          </a:solidFill>
+                          <a:latin typeface="IBM Plex Sans KR" pitchFamily="34" charset="0"/>
+                          <a:ea typeface="IBM Plex Sans KR" pitchFamily="34" charset="-122"/>
+                          <a:cs typeface="IBM Plex Sans KR" pitchFamily="34" charset="-120"/>
+                        </a:rPr>
+                        <a:t>325초</a:t>
+                      </a:r>
+                      <a:endParaRPr lang="en-US" sz="1200" dirty="0">
+                        <a:latin typeface="IBM Plex Sans KR" charset="0"/>
+                        <a:ea typeface="IBM Plex Sans KR" charset="0"/>
+                        <a:cs typeface="IBM Plex Sans KR" charset="0"/>
+                      </a:endParaRPr>
+                    </a:p>
+                  </a:txBody>
+                  <a:tcPr marL="53340" marR="53340" marT="53340" marB="53340" anchor="t">
+                    <a:lnL w="12700" cap="flat" cmpd="sng" algn="ctr">
+                      <a:solidFill>
+                        <a:srgbClr val="C4C4C0"/>
+                      </a:solidFill>
+                      <a:prstDash val="solid"/>
+                      <a:round/>
+                      <a:headEnd type="none" w="med" len="med"/>
+                      <a:tailEnd type="none" w="med" len="med"/>
+                    </a:lnL>
+                    <a:lnR w="12700" cap="flat" cmpd="sng" algn="ctr">
+                      <a:solidFill>
+                        <a:srgbClr val="C4C4C0"/>
+                      </a:solidFill>
+                      <a:prstDash val="solid"/>
+                      <a:round/>
+                      <a:headEnd type="none" w="med" len="med"/>
+                      <a:tailEnd type="none" w="med" len="med"/>
+                    </a:lnR>
+                    <a:lnT w="12700" cap="flat" cmpd="sng" algn="ctr">
+                      <a:solidFill>
+                        <a:srgbClr val="1A202A"/>
+                      </a:solidFill>
+                      <a:prstDash val="solid"/>
+                      <a:round/>
+                      <a:headEnd type="none" w="med" len="med"/>
+                      <a:tailEnd type="none" w="med" len="med"/>
+                    </a:lnT>
+                    <a:lnB w="12700" cap="flat" cmpd="sng" algn="ctr">
+                      <a:solidFill>
+                        <a:srgbClr val="C4C4C0"/>
+                      </a:solidFill>
+                      <a:prstDash val="solid"/>
+                      <a:round/>
+                      <a:headEnd type="none" w="med" len="med"/>
+                      <a:tailEnd type="none" w="med" len="med"/>
+                    </a:lnB>
+                  </a:tcPr>
+                </a:tc>
+                <a:tc>
+                  <a:txBody>
+                    <a:bodyPr/>
+                    <a:lstStyle/>
+                    <a:p>
+                      <a:pPr algn="ctr" indent="0" marL="0">
+                        <a:lnSpc>
+                          <a:spcPts val="1680"/>
+                        </a:lnSpc>
+                        <a:buNone/>
+                      </a:pPr>
+                      <a:r>
+                        <a:rPr lang="en-US" sz="1200" dirty="0">
+                          <a:solidFill>
+                            <a:srgbClr val="3E4A57"/>
+                          </a:solidFill>
+                          <a:latin typeface="IBM Plex Sans KR" pitchFamily="34" charset="0"/>
+                          <a:ea typeface="IBM Plex Sans KR" pitchFamily="34" charset="-122"/>
+                          <a:cs typeface="IBM Plex Sans KR" pitchFamily="34" charset="-120"/>
+                        </a:rPr>
+                        <a:t>3/4</a:t>
+                      </a:r>
+                      <a:endParaRPr lang="en-US" sz="1200" dirty="0">
+                        <a:latin typeface="IBM Plex Sans KR" charset="0"/>
+                        <a:ea typeface="IBM Plex Sans KR" charset="0"/>
+                        <a:cs typeface="IBM Plex Sans KR" charset="0"/>
+                      </a:endParaRPr>
+                    </a:p>
+                  </a:txBody>
+                  <a:tcPr marL="53340" marR="53340" marT="53340" marB="53340" anchor="t">
+                    <a:lnL w="12700" cap="flat" cmpd="sng" algn="ctr">
+                      <a:solidFill>
+                        <a:srgbClr val="C4C4C0"/>
+                      </a:solidFill>
+                      <a:prstDash val="solid"/>
+                      <a:round/>
+                      <a:headEnd type="none" w="med" len="med"/>
+                      <a:tailEnd type="none" w="med" len="med"/>
+                    </a:lnL>
+                    <a:lnR w="12700" cap="flat" cmpd="sng" algn="ctr">
+                      <a:solidFill>
+                        <a:srgbClr val="C4C4C0"/>
+                      </a:solidFill>
+                      <a:prstDash val="solid"/>
+                      <a:round/>
+                      <a:headEnd type="none" w="med" len="med"/>
+                      <a:tailEnd type="none" w="med" len="med"/>
+                    </a:lnR>
+                    <a:lnT w="12700" cap="flat" cmpd="sng" algn="ctr">
+                      <a:solidFill>
+                        <a:srgbClr val="1A202A"/>
+                      </a:solidFill>
+                      <a:prstDash val="solid"/>
+                      <a:round/>
+                      <a:headEnd type="none" w="med" len="med"/>
+                      <a:tailEnd type="none" w="med" len="med"/>
+                    </a:lnT>
+                    <a:lnB w="12700" cap="flat" cmpd="sng" algn="ctr">
+                      <a:solidFill>
+                        <a:srgbClr val="C4C4C0"/>
+                      </a:solidFill>
+                      <a:prstDash val="solid"/>
+                      <a:round/>
+                      <a:headEnd type="none" w="med" len="med"/>
+                      <a:tailEnd type="none" w="med" len="med"/>
+                    </a:lnB>
+                  </a:tcPr>
+                </a:tc>
+                <a:tc>
+                  <a:txBody>
+                    <a:bodyPr/>
+                    <a:lstStyle/>
+                    <a:p>
+                      <a:pPr algn="ctr" indent="0" marL="0">
+                        <a:lnSpc>
+                          <a:spcPts val="1680"/>
+                        </a:lnSpc>
+                        <a:buNone/>
+                      </a:pPr>
+                      <a:r>
+                        <a:rPr lang="en-US" sz="1200" dirty="0">
+                          <a:solidFill>
+                            <a:srgbClr val="3E4A57"/>
+                          </a:solidFill>
+                          <a:latin typeface="IBM Plex Sans KR" pitchFamily="34" charset="0"/>
+                          <a:ea typeface="IBM Plex Sans KR" pitchFamily="34" charset="-122"/>
+                          <a:cs typeface="IBM Plex Sans KR" pitchFamily="34" charset="-120"/>
+                        </a:rPr>
+                        <a:t>4.8만</a:t>
+                      </a:r>
+                      <a:endParaRPr lang="en-US" sz="1200" dirty="0">
+                        <a:latin typeface="IBM Plex Sans KR" charset="0"/>
+                        <a:ea typeface="IBM Plex Sans KR" charset="0"/>
+                        <a:cs typeface="IBM Plex Sans KR" charset="0"/>
+                      </a:endParaRPr>
+                    </a:p>
+                  </a:txBody>
+                  <a:tcPr marL="53340" marR="53340" marT="53340" marB="53340" anchor="t">
+                    <a:lnL w="12700" cap="flat" cmpd="sng" algn="ctr">
+                      <a:solidFill>
+                        <a:srgbClr val="C4C4C0"/>
+                      </a:solidFill>
+                      <a:prstDash val="solid"/>
+                      <a:round/>
+                      <a:headEnd type="none" w="med" len="med"/>
+                      <a:tailEnd type="none" w="med" len="med"/>
+                    </a:lnL>
+                    <a:lnR w="12700" cap="flat" cmpd="sng" algn="ctr">
+                      <a:solidFill>
+                        <a:srgbClr val="C4C4C0"/>
+                      </a:solidFill>
+                      <a:prstDash val="solid"/>
+                      <a:round/>
+                      <a:headEnd type="none" w="med" len="med"/>
+                      <a:tailEnd type="none" w="med" len="med"/>
+                    </a:lnR>
+                    <a:lnT w="12700" cap="flat" cmpd="sng" algn="ctr">
+                      <a:solidFill>
+                        <a:srgbClr val="1A202A"/>
+                      </a:solidFill>
+                      <a:prstDash val="solid"/>
+                      <a:round/>
+                      <a:headEnd type="none" w="med" len="med"/>
+                      <a:tailEnd type="none" w="med" len="med"/>
+                    </a:lnT>
+                    <a:lnB w="12700" cap="flat" cmpd="sng" algn="ctr">
+                      <a:solidFill>
+                        <a:srgbClr val="C4C4C0"/>
+                      </a:solidFill>
+                      <a:prstDash val="solid"/>
+                      <a:round/>
+                      <a:headEnd type="none" w="med" len="med"/>
+                      <a:tailEnd type="none" w="med" len="med"/>
+                    </a:lnB>
+                  </a:tcPr>
+                </a:tc>
+              </a:tr>
+              <a:tr h="332680">
+                <a:tc>
+                  <a:txBody>
+                    <a:bodyPr/>
+                    <a:lstStyle/>
+                    <a:p>
+                      <a:pPr indent="0" marL="0">
+                        <a:lnSpc>
+                          <a:spcPts val="1680"/>
+                        </a:lnSpc>
+                        <a:buNone/>
+                      </a:pPr>
+                      <a:r>
+                        <a:rPr lang="en-US" sz="1200" dirty="0">
+                          <a:solidFill>
+                            <a:srgbClr val="3E4A57"/>
+                          </a:solidFill>
+                          <a:latin typeface="IBM Plex Sans KR" pitchFamily="34" charset="0"/>
+                          <a:ea typeface="IBM Plex Sans KR" pitchFamily="34" charset="-122"/>
+                          <a:cs typeface="IBM Plex Sans KR" pitchFamily="34" charset="-120"/>
+                        </a:rPr>
+                        <a:t>B 있음</a:t>
+                      </a:r>
+                      <a:endParaRPr lang="en-US" sz="1200" dirty="0">
+                        <a:latin typeface="IBM Plex Sans KR" charset="0"/>
+                        <a:ea typeface="IBM Plex Sans KR" charset="0"/>
+                        <a:cs typeface="IBM Plex Sans KR" charset="0"/>
+                      </a:endParaRPr>
+                    </a:p>
+                  </a:txBody>
+                  <a:tcPr marL="53340" marR="53340" marT="53340" marB="53340" anchor="t">
+                    <a:lnL w="12700" cap="flat" cmpd="sng" algn="ctr">
+                      <a:solidFill>
+                        <a:srgbClr val="C4C4C0"/>
+                      </a:solidFill>
+                      <a:prstDash val="solid"/>
+                      <a:round/>
+                      <a:headEnd type="none" w="med" len="med"/>
+                      <a:tailEnd type="none" w="med" len="med"/>
+                    </a:lnL>
+                    <a:lnR w="12700" cap="flat" cmpd="sng" algn="ctr">
+                      <a:solidFill>
+                        <a:srgbClr val="CBCBC8"/>
+                      </a:solidFill>
+                      <a:prstDash val="solid"/>
+                      <a:round/>
+                      <a:headEnd type="none" w="med" len="med"/>
+                      <a:tailEnd type="none" w="med" len="med"/>
+                    </a:lnR>
+                    <a:lnT w="12700" cap="flat" cmpd="sng" algn="ctr">
+                      <a:solidFill>
+                        <a:srgbClr val="C4C4C0"/>
+                      </a:solidFill>
+                      <a:prstDash val="solid"/>
+                      <a:round/>
+                      <a:headEnd type="none" w="med" len="med"/>
+                      <a:tailEnd type="none" w="med" len="med"/>
+                    </a:lnT>
+                    <a:lnB w="12700" cap="flat" cmpd="sng" algn="ctr">
+                      <a:solidFill>
+                        <a:srgbClr val="CBCBC8"/>
+                      </a:solidFill>
+                      <a:prstDash val="solid"/>
+                      <a:round/>
+                      <a:headEnd type="none" w="med" len="med"/>
+                      <a:tailEnd type="none" w="med" len="med"/>
+                    </a:lnB>
+                    <a:solidFill>
+                      <a:srgbClr val="FFFEFB"/>
+                    </a:solidFill>
+                  </a:tcPr>
+                </a:tc>
+                <a:tc>
+                  <a:txBody>
+                    <a:bodyPr/>
+                    <a:lstStyle/>
+                    <a:p>
+                      <a:pPr algn="ctr" indent="0" marL="0">
+                        <a:lnSpc>
+                          <a:spcPts val="1680"/>
+                        </a:lnSpc>
+                        <a:buNone/>
+                      </a:pPr>
+                      <a:r>
+                        <a:rPr lang="en-US" sz="1200" dirty="0">
+                          <a:solidFill>
+                            <a:srgbClr val="2F6E9A"/>
+                          </a:solidFill>
+                          <a:latin typeface="IBM Plex Sans KR" pitchFamily="34" charset="0"/>
+                          <a:ea typeface="IBM Plex Sans KR" pitchFamily="34" charset="-122"/>
+                          <a:cs typeface="IBM Plex Sans KR" pitchFamily="34" charset="-120"/>
+                        </a:rPr>
+                        <a:t>0.2</a:t>
+                      </a:r>
+                      <a:endParaRPr lang="en-US" sz="1200" dirty="0">
+                        <a:latin typeface="IBM Plex Sans KR" charset="0"/>
+                        <a:ea typeface="IBM Plex Sans KR" charset="0"/>
+                        <a:cs typeface="IBM Plex Sans KR" charset="0"/>
+                      </a:endParaRPr>
+                    </a:p>
+                  </a:txBody>
+                  <a:tcPr marL="53340" marR="53340" marT="53340" marB="53340" anchor="t">
+                    <a:lnL w="12700" cap="flat" cmpd="sng" algn="ctr">
+                      <a:solidFill>
+                        <a:srgbClr val="CBCBC8"/>
+                      </a:solidFill>
+                      <a:prstDash val="solid"/>
+                      <a:round/>
+                      <a:headEnd type="none" w="med" len="med"/>
+                      <a:tailEnd type="none" w="med" len="med"/>
+                    </a:lnL>
+                    <a:lnR w="12700" cap="flat" cmpd="sng" algn="ctr">
+                      <a:solidFill>
+                        <a:srgbClr val="CBCBC8"/>
+                      </a:solidFill>
+                      <a:prstDash val="solid"/>
+                      <a:round/>
+                      <a:headEnd type="none" w="med" len="med"/>
+                      <a:tailEnd type="none" w="med" len="med"/>
+                    </a:lnR>
+                    <a:lnT w="12700" cap="flat" cmpd="sng" algn="ctr">
+                      <a:solidFill>
+                        <a:srgbClr val="C4C4C0"/>
+                      </a:solidFill>
+                      <a:prstDash val="solid"/>
+                      <a:round/>
+                      <a:headEnd type="none" w="med" len="med"/>
+                      <a:tailEnd type="none" w="med" len="med"/>
+                    </a:lnT>
+                    <a:lnB w="12700" cap="flat" cmpd="sng" algn="ctr">
+                      <a:solidFill>
+                        <a:srgbClr val="CBCBC8"/>
+                      </a:solidFill>
+                      <a:prstDash val="solid"/>
+                      <a:round/>
+                      <a:headEnd type="none" w="med" len="med"/>
+                      <a:tailEnd type="none" w="med" len="med"/>
+                    </a:lnB>
+                    <a:solidFill>
+                      <a:srgbClr val="FFFEFB"/>
+                    </a:solidFill>
+                  </a:tcPr>
+                </a:tc>
+                <a:tc>
+                  <a:txBody>
+                    <a:bodyPr/>
+                    <a:lstStyle/>
+                    <a:p>
+                      <a:pPr algn="ctr" indent="0" marL="0">
+                        <a:lnSpc>
+                          <a:spcPts val="1680"/>
+                        </a:lnSpc>
+                        <a:buNone/>
+                      </a:pPr>
+                      <a:r>
+                        <a:rPr lang="en-US" sz="1200" dirty="0">
+                          <a:solidFill>
+                            <a:srgbClr val="2F6E9A"/>
+                          </a:solidFill>
+                          <a:latin typeface="IBM Plex Sans KR" pitchFamily="34" charset="0"/>
+                          <a:ea typeface="IBM Plex Sans KR" pitchFamily="34" charset="-122"/>
+                          <a:cs typeface="IBM Plex Sans KR" pitchFamily="34" charset="-120"/>
+                        </a:rPr>
+                        <a:t>137초</a:t>
+                      </a:r>
+                      <a:endParaRPr lang="en-US" sz="1200" dirty="0">
+                        <a:latin typeface="IBM Plex Sans KR" charset="0"/>
+                        <a:ea typeface="IBM Plex Sans KR" charset="0"/>
+                        <a:cs typeface="IBM Plex Sans KR" charset="0"/>
+                      </a:endParaRPr>
+                    </a:p>
+                  </a:txBody>
+                  <a:tcPr marL="53340" marR="53340" marT="53340" marB="53340" anchor="t">
+                    <a:lnL w="12700" cap="flat" cmpd="sng" algn="ctr">
+                      <a:solidFill>
+                        <a:srgbClr val="CBCBC8"/>
+                      </a:solidFill>
+                      <a:prstDash val="solid"/>
+                      <a:round/>
+                      <a:headEnd type="none" w="med" len="med"/>
+                      <a:tailEnd type="none" w="med" len="med"/>
+                    </a:lnL>
+                    <a:lnR w="12700" cap="flat" cmpd="sng" algn="ctr">
+                      <a:solidFill>
+                        <a:srgbClr val="CBCBC8"/>
+                      </a:solidFill>
+                      <a:prstDash val="solid"/>
+                      <a:round/>
+                      <a:headEnd type="none" w="med" len="med"/>
+                      <a:tailEnd type="none" w="med" len="med"/>
+                    </a:lnR>
+                    <a:lnT w="12700" cap="flat" cmpd="sng" algn="ctr">
+                      <a:solidFill>
+                        <a:srgbClr val="C4C4C0"/>
+                      </a:solidFill>
+                      <a:prstDash val="solid"/>
+                      <a:round/>
+                      <a:headEnd type="none" w="med" len="med"/>
+                      <a:tailEnd type="none" w="med" len="med"/>
+                    </a:lnT>
+                    <a:lnB w="12700" cap="flat" cmpd="sng" algn="ctr">
+                      <a:solidFill>
+                        <a:srgbClr val="CBCBC8"/>
+                      </a:solidFill>
+                      <a:prstDash val="solid"/>
+                      <a:round/>
+                      <a:headEnd type="none" w="med" len="med"/>
+                      <a:tailEnd type="none" w="med" len="med"/>
+                    </a:lnB>
+                    <a:solidFill>
+                      <a:srgbClr val="FFFEFB"/>
+                    </a:solidFill>
+                  </a:tcPr>
+                </a:tc>
+                <a:tc>
+                  <a:txBody>
+                    <a:bodyPr/>
+                    <a:lstStyle/>
+                    <a:p>
+                      <a:pPr algn="ctr" indent="0" marL="0">
+                        <a:lnSpc>
+                          <a:spcPts val="1680"/>
+                        </a:lnSpc>
+                        <a:buNone/>
+                      </a:pPr>
+                      <a:r>
+                        <a:rPr lang="en-US" sz="1200" dirty="0">
+                          <a:solidFill>
+                            <a:srgbClr val="2F6E9A"/>
+                          </a:solidFill>
+                          <a:latin typeface="IBM Plex Sans KR" pitchFamily="34" charset="0"/>
+                          <a:ea typeface="IBM Plex Sans KR" pitchFamily="34" charset="-122"/>
+                          <a:cs typeface="IBM Plex Sans KR" pitchFamily="34" charset="-120"/>
+                        </a:rPr>
+                        <a:t>12/12</a:t>
+                      </a:r>
+                      <a:endParaRPr lang="en-US" sz="1200" dirty="0">
+                        <a:latin typeface="IBM Plex Sans KR" charset="0"/>
+                        <a:ea typeface="IBM Plex Sans KR" charset="0"/>
+                        <a:cs typeface="IBM Plex Sans KR" charset="0"/>
+                      </a:endParaRPr>
+                    </a:p>
+                  </a:txBody>
+                  <a:tcPr marL="53340" marR="53340" marT="53340" marB="53340" anchor="t">
+                    <a:lnL w="12700" cap="flat" cmpd="sng" algn="ctr">
+                      <a:solidFill>
+                        <a:srgbClr val="CBCBC8"/>
+                      </a:solidFill>
+                      <a:prstDash val="solid"/>
+                      <a:round/>
+                      <a:headEnd type="none" w="med" len="med"/>
+                      <a:tailEnd type="none" w="med" len="med"/>
+                    </a:lnL>
+                    <a:lnR w="12700" cap="flat" cmpd="sng" algn="ctr">
+                      <a:solidFill>
+                        <a:srgbClr val="CBCBC8"/>
+                      </a:solidFill>
+                      <a:prstDash val="solid"/>
+                      <a:round/>
+                      <a:headEnd type="none" w="med" len="med"/>
+                      <a:tailEnd type="none" w="med" len="med"/>
+                    </a:lnR>
+                    <a:lnT w="12700" cap="flat" cmpd="sng" algn="ctr">
+                      <a:solidFill>
+                        <a:srgbClr val="C4C4C0"/>
+                      </a:solidFill>
+                      <a:prstDash val="solid"/>
+                      <a:round/>
+                      <a:headEnd type="none" w="med" len="med"/>
+                      <a:tailEnd type="none" w="med" len="med"/>
+                    </a:lnT>
+                    <a:lnB w="12700" cap="flat" cmpd="sng" algn="ctr">
+                      <a:solidFill>
+                        <a:srgbClr val="CBCBC8"/>
+                      </a:solidFill>
+                      <a:prstDash val="solid"/>
+                      <a:round/>
+                      <a:headEnd type="none" w="med" len="med"/>
+                      <a:tailEnd type="none" w="med" len="med"/>
+                    </a:lnB>
+                    <a:solidFill>
+                      <a:srgbClr val="FFFEFB"/>
+                    </a:solidFill>
+                  </a:tcPr>
+                </a:tc>
+                <a:tc>
+                  <a:txBody>
+                    <a:bodyPr/>
+                    <a:lstStyle/>
+                    <a:p>
+                      <a:pPr algn="ctr" indent="0" marL="0">
+                        <a:lnSpc>
+                          <a:spcPts val="1680"/>
+                        </a:lnSpc>
+                        <a:buNone/>
+                      </a:pPr>
+                      <a:r>
+                        <a:rPr lang="en-US" sz="1200" dirty="0">
+                          <a:solidFill>
+                            <a:srgbClr val="3E4A57"/>
+                          </a:solidFill>
+                          <a:latin typeface="IBM Plex Sans KR" pitchFamily="34" charset="0"/>
+                          <a:ea typeface="IBM Plex Sans KR" pitchFamily="34" charset="-122"/>
+                          <a:cs typeface="IBM Plex Sans KR" pitchFamily="34" charset="-120"/>
+                        </a:rPr>
+                        <a:t>5.0만</a:t>
+                      </a:r>
+                      <a:endParaRPr lang="en-US" sz="1200" dirty="0">
+                        <a:latin typeface="IBM Plex Sans KR" charset="0"/>
+                        <a:ea typeface="IBM Plex Sans KR" charset="0"/>
+                        <a:cs typeface="IBM Plex Sans KR" charset="0"/>
+                      </a:endParaRPr>
+                    </a:p>
+                  </a:txBody>
+                  <a:tcPr marL="53340" marR="53340" marT="53340" marB="53340" anchor="t">
+                    <a:lnL w="12700" cap="flat" cmpd="sng" algn="ctr">
+                      <a:solidFill>
+                        <a:srgbClr val="CBCBC8"/>
+                      </a:solidFill>
+                      <a:prstDash val="solid"/>
+                      <a:round/>
+                      <a:headEnd type="none" w="med" len="med"/>
+                      <a:tailEnd type="none" w="med" len="med"/>
+                    </a:lnL>
+                    <a:lnR w="12700" cap="flat" cmpd="sng" algn="ctr">
+                      <a:solidFill>
+                        <a:srgbClr val="CBCBC8"/>
+                      </a:solidFill>
+                      <a:prstDash val="solid"/>
+                      <a:round/>
+                      <a:headEnd type="none" w="med" len="med"/>
+                      <a:tailEnd type="none" w="med" len="med"/>
+                    </a:lnR>
+                    <a:lnT w="12700" cap="flat" cmpd="sng" algn="ctr">
+                      <a:solidFill>
+                        <a:srgbClr val="C4C4C0"/>
+                      </a:solidFill>
+                      <a:prstDash val="solid"/>
+                      <a:round/>
+                      <a:headEnd type="none" w="med" len="med"/>
+                      <a:tailEnd type="none" w="med" len="med"/>
+                    </a:lnT>
+                    <a:lnB w="12700" cap="flat" cmpd="sng" algn="ctr">
+                      <a:solidFill>
+                        <a:srgbClr val="CBCBC8"/>
+                      </a:solidFill>
+                      <a:prstDash val="solid"/>
+                      <a:round/>
+                      <a:headEnd type="none" w="med" len="med"/>
+                      <a:tailEnd type="none" w="med" len="med"/>
+                    </a:lnB>
+                    <a:solidFill>
+                      <a:srgbClr val="FFFEFB"/>
+                    </a:solidFill>
+                  </a:tcPr>
+                </a:tc>
+              </a:tr>
+              <a:tr h="332680">
+                <a:tc>
+                  <a:txBody>
+                    <a:bodyPr/>
+                    <a:lstStyle/>
+                    <a:p>
+                      <a:pPr indent="0" marL="0">
+                        <a:lnSpc>
+                          <a:spcPts val="1680"/>
+                        </a:lnSpc>
+                        <a:buNone/>
+                      </a:pPr>
+                      <a:r>
+                        <a:rPr lang="en-US" sz="1200" dirty="0">
+                          <a:solidFill>
+                            <a:srgbClr val="3E4A57"/>
+                          </a:solidFill>
+                          <a:latin typeface="IBM Plex Sans KR" pitchFamily="34" charset="0"/>
+                          <a:ea typeface="IBM Plex Sans KR" pitchFamily="34" charset="-122"/>
+                          <a:cs typeface="IBM Plex Sans KR" pitchFamily="34" charset="-120"/>
+                        </a:rPr>
+                        <a:t>C 없음</a:t>
+                      </a:r>
+                      <a:endParaRPr lang="en-US" sz="1200" dirty="0">
+                        <a:latin typeface="IBM Plex Sans KR" charset="0"/>
+                        <a:ea typeface="IBM Plex Sans KR" charset="0"/>
+                        <a:cs typeface="IBM Plex Sans KR" charset="0"/>
+                      </a:endParaRPr>
+                    </a:p>
+                  </a:txBody>
+                  <a:tcPr marL="53340" marR="53340" marT="53340" marB="53340" anchor="t">
+                    <a:lnL w="12700" cap="flat" cmpd="sng" algn="ctr">
+                      <a:solidFill>
+                        <a:srgbClr val="C4C4C0"/>
+                      </a:solidFill>
+                      <a:prstDash val="solid"/>
+                      <a:round/>
+                      <a:headEnd type="none" w="med" len="med"/>
+                      <a:tailEnd type="none" w="med" len="med"/>
+                    </a:lnL>
+                    <a:lnR w="12700" cap="flat" cmpd="sng" algn="ctr">
+                      <a:solidFill>
+                        <a:srgbClr val="C4C4C0"/>
+                      </a:solidFill>
+                      <a:prstDash val="solid"/>
+                      <a:round/>
+                      <a:headEnd type="none" w="med" len="med"/>
+                      <a:tailEnd type="none" w="med" len="med"/>
+                    </a:lnR>
+                    <a:lnT w="12700" cap="flat" cmpd="sng" algn="ctr">
+                      <a:solidFill>
+                        <a:srgbClr val="CBCBC8"/>
+                      </a:solidFill>
+                      <a:prstDash val="solid"/>
+                      <a:round/>
+                      <a:headEnd type="none" w="med" len="med"/>
+                      <a:tailEnd type="none" w="med" len="med"/>
+                    </a:lnT>
+                    <a:lnB w="12700" cap="flat" cmpd="sng" algn="ctr">
+                      <a:solidFill>
+                        <a:srgbClr val="C4C4C0"/>
+                      </a:solidFill>
+                      <a:prstDash val="solid"/>
+                      <a:round/>
+                      <a:headEnd type="none" w="med" len="med"/>
+                      <a:tailEnd type="none" w="med" len="med"/>
+                    </a:lnB>
+                  </a:tcPr>
+                </a:tc>
+                <a:tc>
+                  <a:txBody>
+                    <a:bodyPr/>
+                    <a:lstStyle/>
+                    <a:p>
+                      <a:pPr algn="ctr" indent="0" marL="0">
+                        <a:lnSpc>
+                          <a:spcPts val="1680"/>
+                        </a:lnSpc>
+                        <a:buNone/>
+                      </a:pPr>
+                      <a:r>
+                        <a:rPr lang="en-US" sz="1200" dirty="0">
+                          <a:solidFill>
+                            <a:srgbClr val="3E4A57"/>
+                          </a:solidFill>
+                          <a:latin typeface="IBM Plex Sans KR" pitchFamily="34" charset="0"/>
+                          <a:ea typeface="IBM Plex Sans KR" pitchFamily="34" charset="-122"/>
+                          <a:cs typeface="IBM Plex Sans KR" pitchFamily="34" charset="-120"/>
+                        </a:rPr>
+                        <a:t>43.8</a:t>
+                      </a:r>
+                      <a:endParaRPr lang="en-US" sz="1200" dirty="0">
+                        <a:latin typeface="IBM Plex Sans KR" charset="0"/>
+                        <a:ea typeface="IBM Plex Sans KR" charset="0"/>
+                        <a:cs typeface="IBM Plex Sans KR" charset="0"/>
+                      </a:endParaRPr>
+                    </a:p>
+                  </a:txBody>
+                  <a:tcPr marL="53340" marR="53340" marT="53340" marB="53340" anchor="t">
+                    <a:lnL w="12700" cap="flat" cmpd="sng" algn="ctr">
+                      <a:solidFill>
+                        <a:srgbClr val="C4C4C0"/>
+                      </a:solidFill>
+                      <a:prstDash val="solid"/>
+                      <a:round/>
+                      <a:headEnd type="none" w="med" len="med"/>
+                      <a:tailEnd type="none" w="med" len="med"/>
+                    </a:lnL>
+                    <a:lnR w="12700" cap="flat" cmpd="sng" algn="ctr">
+                      <a:solidFill>
+                        <a:srgbClr val="C4C4C0"/>
+                      </a:solidFill>
+                      <a:prstDash val="solid"/>
+                      <a:round/>
+                      <a:headEnd type="none" w="med" len="med"/>
+                      <a:tailEnd type="none" w="med" len="med"/>
+                    </a:lnR>
+                    <a:lnT w="12700" cap="flat" cmpd="sng" algn="ctr">
+                      <a:solidFill>
+                        <a:srgbClr val="CBCBC8"/>
+                      </a:solidFill>
+                      <a:prstDash val="solid"/>
+                      <a:round/>
+                      <a:headEnd type="none" w="med" len="med"/>
+                      <a:tailEnd type="none" w="med" len="med"/>
+                    </a:lnT>
+                    <a:lnB w="12700" cap="flat" cmpd="sng" algn="ctr">
+                      <a:solidFill>
+                        <a:srgbClr val="C4C4C0"/>
+                      </a:solidFill>
+                      <a:prstDash val="solid"/>
+                      <a:round/>
+                      <a:headEnd type="none" w="med" len="med"/>
+                      <a:tailEnd type="none" w="med" len="med"/>
+                    </a:lnB>
+                  </a:tcPr>
+                </a:tc>
+                <a:tc>
+                  <a:txBody>
+                    <a:bodyPr/>
+                    <a:lstStyle/>
+                    <a:p>
+                      <a:pPr algn="ctr" indent="0" marL="0">
+                        <a:lnSpc>
+                          <a:spcPts val="1680"/>
+                        </a:lnSpc>
+                        <a:buNone/>
+                      </a:pPr>
+                      <a:r>
+                        <a:rPr lang="en-US" sz="1200" dirty="0">
+                          <a:solidFill>
+                            <a:srgbClr val="3E4A57"/>
+                          </a:solidFill>
+                          <a:latin typeface="IBM Plex Sans KR" pitchFamily="34" charset="0"/>
+                          <a:ea typeface="IBM Plex Sans KR" pitchFamily="34" charset="-122"/>
+                          <a:cs typeface="IBM Plex Sans KR" pitchFamily="34" charset="-120"/>
+                        </a:rPr>
+                        <a:t>300초</a:t>
+                      </a:r>
+                      <a:endParaRPr lang="en-US" sz="1200" dirty="0">
+                        <a:latin typeface="IBM Plex Sans KR" charset="0"/>
+                        <a:ea typeface="IBM Plex Sans KR" charset="0"/>
+                        <a:cs typeface="IBM Plex Sans KR" charset="0"/>
+                      </a:endParaRPr>
+                    </a:p>
+                  </a:txBody>
+                  <a:tcPr marL="53340" marR="53340" marT="53340" marB="53340" anchor="t">
+                    <a:lnL w="12700" cap="flat" cmpd="sng" algn="ctr">
+                      <a:solidFill>
+                        <a:srgbClr val="C4C4C0"/>
+                      </a:solidFill>
+                      <a:prstDash val="solid"/>
+                      <a:round/>
+                      <a:headEnd type="none" w="med" len="med"/>
+                      <a:tailEnd type="none" w="med" len="med"/>
+                    </a:lnL>
+                    <a:lnR w="12700" cap="flat" cmpd="sng" algn="ctr">
+                      <a:solidFill>
+                        <a:srgbClr val="C4C4C0"/>
+                      </a:solidFill>
+                      <a:prstDash val="solid"/>
+                      <a:round/>
+                      <a:headEnd type="none" w="med" len="med"/>
+                      <a:tailEnd type="none" w="med" len="med"/>
+                    </a:lnR>
+                    <a:lnT w="12700" cap="flat" cmpd="sng" algn="ctr">
+                      <a:solidFill>
+                        <a:srgbClr val="CBCBC8"/>
+                      </a:solidFill>
+                      <a:prstDash val="solid"/>
+                      <a:round/>
+                      <a:headEnd type="none" w="med" len="med"/>
+                      <a:tailEnd type="none" w="med" len="med"/>
+                    </a:lnT>
+                    <a:lnB w="12700" cap="flat" cmpd="sng" algn="ctr">
+                      <a:solidFill>
+                        <a:srgbClr val="C4C4C0"/>
+                      </a:solidFill>
+                      <a:prstDash val="solid"/>
+                      <a:round/>
+                      <a:headEnd type="none" w="med" len="med"/>
+                      <a:tailEnd type="none" w="med" len="med"/>
+                    </a:lnB>
+                  </a:tcPr>
+                </a:tc>
+                <a:tc>
+                  <a:txBody>
+                    <a:bodyPr/>
+                    <a:lstStyle/>
+                    <a:p>
+                      <a:pPr algn="ctr" indent="0" marL="0">
+                        <a:lnSpc>
+                          <a:spcPts val="1680"/>
+                        </a:lnSpc>
+                        <a:buNone/>
+                      </a:pPr>
+                      <a:r>
+                        <a:rPr lang="en-US" sz="1200" dirty="0">
+                          <a:solidFill>
+                            <a:srgbClr val="3E4A57"/>
+                          </a:solidFill>
+                          <a:latin typeface="IBM Plex Sans KR" pitchFamily="34" charset="0"/>
+                          <a:ea typeface="IBM Plex Sans KR" pitchFamily="34" charset="-122"/>
+                          <a:cs typeface="IBM Plex Sans KR" pitchFamily="34" charset="-120"/>
+                        </a:rPr>
+                        <a:t>3/4</a:t>
+                      </a:r>
+                      <a:endParaRPr lang="en-US" sz="1200" dirty="0">
+                        <a:latin typeface="IBM Plex Sans KR" charset="0"/>
+                        <a:ea typeface="IBM Plex Sans KR" charset="0"/>
+                        <a:cs typeface="IBM Plex Sans KR" charset="0"/>
+                      </a:endParaRPr>
+                    </a:p>
+                  </a:txBody>
+                  <a:tcPr marL="53340" marR="53340" marT="53340" marB="53340" anchor="t">
+                    <a:lnL w="12700" cap="flat" cmpd="sng" algn="ctr">
+                      <a:solidFill>
+                        <a:srgbClr val="C4C4C0"/>
+                      </a:solidFill>
+                      <a:prstDash val="solid"/>
+                      <a:round/>
+                      <a:headEnd type="none" w="med" len="med"/>
+                      <a:tailEnd type="none" w="med" len="med"/>
+                    </a:lnL>
+                    <a:lnR w="12700" cap="flat" cmpd="sng" algn="ctr">
+                      <a:solidFill>
+                        <a:srgbClr val="C4C4C0"/>
+                      </a:solidFill>
+                      <a:prstDash val="solid"/>
+                      <a:round/>
+                      <a:headEnd type="none" w="med" len="med"/>
+                      <a:tailEnd type="none" w="med" len="med"/>
+                    </a:lnR>
+                    <a:lnT w="12700" cap="flat" cmpd="sng" algn="ctr">
+                      <a:solidFill>
+                        <a:srgbClr val="CBCBC8"/>
+                      </a:solidFill>
+                      <a:prstDash val="solid"/>
+                      <a:round/>
+                      <a:headEnd type="none" w="med" len="med"/>
+                      <a:tailEnd type="none" w="med" len="med"/>
+                    </a:lnT>
+                    <a:lnB w="12700" cap="flat" cmpd="sng" algn="ctr">
+                      <a:solidFill>
+                        <a:srgbClr val="C4C4C0"/>
+                      </a:solidFill>
+                      <a:prstDash val="solid"/>
+                      <a:round/>
+                      <a:headEnd type="none" w="med" len="med"/>
+                      <a:tailEnd type="none" w="med" len="med"/>
+                    </a:lnB>
+                  </a:tcPr>
+                </a:tc>
+                <a:tc>
+                  <a:txBody>
+                    <a:bodyPr/>
+                    <a:lstStyle/>
+                    <a:p>
+                      <a:pPr algn="ctr" indent="0" marL="0">
+                        <a:lnSpc>
+                          <a:spcPts val="1680"/>
+                        </a:lnSpc>
+                        <a:buNone/>
+                      </a:pPr>
+                      <a:r>
+                        <a:rPr lang="en-US" sz="1200" dirty="0">
+                          <a:solidFill>
+                            <a:srgbClr val="3E4A57"/>
+                          </a:solidFill>
+                          <a:latin typeface="IBM Plex Sans KR" pitchFamily="34" charset="0"/>
+                          <a:ea typeface="IBM Plex Sans KR" pitchFamily="34" charset="-122"/>
+                          <a:cs typeface="IBM Plex Sans KR" pitchFamily="34" charset="-120"/>
+                        </a:rPr>
+                        <a:t>9.2만</a:t>
+                      </a:r>
+                      <a:endParaRPr lang="en-US" sz="1200" dirty="0">
+                        <a:latin typeface="IBM Plex Sans KR" charset="0"/>
+                        <a:ea typeface="IBM Plex Sans KR" charset="0"/>
+                        <a:cs typeface="IBM Plex Sans KR" charset="0"/>
+                      </a:endParaRPr>
+                    </a:p>
+                  </a:txBody>
+                  <a:tcPr marL="53340" marR="53340" marT="53340" marB="53340" anchor="t">
+                    <a:lnL w="12700" cap="flat" cmpd="sng" algn="ctr">
+                      <a:solidFill>
+                        <a:srgbClr val="C4C4C0"/>
+                      </a:solidFill>
+                      <a:prstDash val="solid"/>
+                      <a:round/>
+                      <a:headEnd type="none" w="med" len="med"/>
+                      <a:tailEnd type="none" w="med" len="med"/>
+                    </a:lnL>
+                    <a:lnR w="12700" cap="flat" cmpd="sng" algn="ctr">
+                      <a:solidFill>
+                        <a:srgbClr val="C4C4C0"/>
+                      </a:solidFill>
+                      <a:prstDash val="solid"/>
+                      <a:round/>
+                      <a:headEnd type="none" w="med" len="med"/>
+                      <a:tailEnd type="none" w="med" len="med"/>
+                    </a:lnR>
+                    <a:lnT w="12700" cap="flat" cmpd="sng" algn="ctr">
+                      <a:solidFill>
+                        <a:srgbClr val="CBCBC8"/>
+                      </a:solidFill>
+                      <a:prstDash val="solid"/>
+                      <a:round/>
+                      <a:headEnd type="none" w="med" len="med"/>
+                      <a:tailEnd type="none" w="med" len="med"/>
+                    </a:lnT>
+                    <a:lnB w="12700" cap="flat" cmpd="sng" algn="ctr">
+                      <a:solidFill>
+                        <a:srgbClr val="C4C4C0"/>
+                      </a:solidFill>
+                      <a:prstDash val="solid"/>
+                      <a:round/>
+                      <a:headEnd type="none" w="med" len="med"/>
+                      <a:tailEnd type="none" w="med" len="med"/>
+                    </a:lnB>
+                  </a:tcPr>
+                </a:tc>
+              </a:tr>
+              <a:tr h="332680">
+                <a:tc>
+                  <a:txBody>
+                    <a:bodyPr/>
+                    <a:lstStyle/>
+                    <a:p>
+                      <a:pPr indent="0" marL="0">
+                        <a:lnSpc>
+                          <a:spcPts val="1680"/>
+                        </a:lnSpc>
+                        <a:buNone/>
+                      </a:pPr>
+                      <a:r>
+                        <a:rPr lang="en-US" sz="1200" dirty="0">
+                          <a:solidFill>
+                            <a:srgbClr val="3E4A57"/>
+                          </a:solidFill>
+                          <a:latin typeface="IBM Plex Sans KR" pitchFamily="34" charset="0"/>
+                          <a:ea typeface="IBM Plex Sans KR" pitchFamily="34" charset="-122"/>
+                          <a:cs typeface="IBM Plex Sans KR" pitchFamily="34" charset="-120"/>
+                        </a:rPr>
+                        <a:t>C 있음</a:t>
+                      </a:r>
+                      <a:endParaRPr lang="en-US" sz="1200" dirty="0">
+                        <a:latin typeface="IBM Plex Sans KR" charset="0"/>
+                        <a:ea typeface="IBM Plex Sans KR" charset="0"/>
+                        <a:cs typeface="IBM Plex Sans KR" charset="0"/>
+                      </a:endParaRPr>
+                    </a:p>
+                  </a:txBody>
+                  <a:tcPr marL="53340" marR="53340" marT="53340" marB="53340" anchor="t">
+                    <a:lnL w="12700" cap="flat" cmpd="sng" algn="ctr">
+                      <a:solidFill>
+                        <a:srgbClr val="C4C4C0"/>
+                      </a:solidFill>
+                      <a:prstDash val="solid"/>
+                      <a:round/>
+                      <a:headEnd type="none" w="med" len="med"/>
+                      <a:tailEnd type="none" w="med" len="med"/>
+                    </a:lnL>
+                    <a:lnR w="12700" cap="flat" cmpd="sng" algn="ctr">
+                      <a:solidFill>
+                        <a:srgbClr val="CBCBC8"/>
+                      </a:solidFill>
+                      <a:prstDash val="solid"/>
+                      <a:round/>
+                      <a:headEnd type="none" w="med" len="med"/>
+                      <a:tailEnd type="none" w="med" len="med"/>
+                    </a:lnR>
+                    <a:lnT w="12700" cap="flat" cmpd="sng" algn="ctr">
+                      <a:solidFill>
+                        <a:srgbClr val="C4C4C0"/>
+                      </a:solidFill>
+                      <a:prstDash val="solid"/>
+                      <a:round/>
+                      <a:headEnd type="none" w="med" len="med"/>
+                      <a:tailEnd type="none" w="med" len="med"/>
+                    </a:lnT>
+                    <a:lnB w="12700" cap="flat" cmpd="sng" algn="ctr">
+                      <a:solidFill>
+                        <a:srgbClr val="CBCBC8"/>
+                      </a:solidFill>
+                      <a:prstDash val="solid"/>
+                      <a:round/>
+                      <a:headEnd type="none" w="med" len="med"/>
+                      <a:tailEnd type="none" w="med" len="med"/>
+                    </a:lnB>
+                    <a:solidFill>
+                      <a:srgbClr val="FFFEFB"/>
+                    </a:solidFill>
+                  </a:tcPr>
+                </a:tc>
+                <a:tc>
+                  <a:txBody>
+                    <a:bodyPr/>
+                    <a:lstStyle/>
+                    <a:p>
+                      <a:pPr algn="ctr" indent="0" marL="0">
+                        <a:lnSpc>
+                          <a:spcPts val="1680"/>
+                        </a:lnSpc>
+                        <a:buNone/>
+                      </a:pPr>
+                      <a:r>
+                        <a:rPr lang="en-US" sz="1200" dirty="0">
+                          <a:solidFill>
+                            <a:srgbClr val="2F6E9A"/>
+                          </a:solidFill>
+                          <a:latin typeface="IBM Plex Sans KR" pitchFamily="34" charset="0"/>
+                          <a:ea typeface="IBM Plex Sans KR" pitchFamily="34" charset="-122"/>
+                          <a:cs typeface="IBM Plex Sans KR" pitchFamily="34" charset="-120"/>
+                        </a:rPr>
+                        <a:t>0</a:t>
+                      </a:r>
+                      <a:endParaRPr lang="en-US" sz="1200" dirty="0">
+                        <a:latin typeface="IBM Plex Sans KR" charset="0"/>
+                        <a:ea typeface="IBM Plex Sans KR" charset="0"/>
+                        <a:cs typeface="IBM Plex Sans KR" charset="0"/>
+                      </a:endParaRPr>
+                    </a:p>
+                  </a:txBody>
+                  <a:tcPr marL="53340" marR="53340" marT="53340" marB="53340" anchor="t">
+                    <a:lnL w="12700" cap="flat" cmpd="sng" algn="ctr">
+                      <a:solidFill>
+                        <a:srgbClr val="CBCBC8"/>
+                      </a:solidFill>
+                      <a:prstDash val="solid"/>
+                      <a:round/>
+                      <a:headEnd type="none" w="med" len="med"/>
+                      <a:tailEnd type="none" w="med" len="med"/>
+                    </a:lnL>
+                    <a:lnR w="12700" cap="flat" cmpd="sng" algn="ctr">
+                      <a:solidFill>
+                        <a:srgbClr val="CBCBC8"/>
+                      </a:solidFill>
+                      <a:prstDash val="solid"/>
+                      <a:round/>
+                      <a:headEnd type="none" w="med" len="med"/>
+                      <a:tailEnd type="none" w="med" len="med"/>
+                    </a:lnR>
+                    <a:lnT w="12700" cap="flat" cmpd="sng" algn="ctr">
+                      <a:solidFill>
+                        <a:srgbClr val="C4C4C0"/>
+                      </a:solidFill>
+                      <a:prstDash val="solid"/>
+                      <a:round/>
+                      <a:headEnd type="none" w="med" len="med"/>
+                      <a:tailEnd type="none" w="med" len="med"/>
+                    </a:lnT>
+                    <a:lnB w="12700" cap="flat" cmpd="sng" algn="ctr">
+                      <a:solidFill>
+                        <a:srgbClr val="CBCBC8"/>
+                      </a:solidFill>
+                      <a:prstDash val="solid"/>
+                      <a:round/>
+                      <a:headEnd type="none" w="med" len="med"/>
+                      <a:tailEnd type="none" w="med" len="med"/>
+                    </a:lnB>
+                    <a:solidFill>
+                      <a:srgbClr val="FFFEFB"/>
+                    </a:solidFill>
+                  </a:tcPr>
+                </a:tc>
+                <a:tc>
+                  <a:txBody>
+                    <a:bodyPr/>
+                    <a:lstStyle/>
+                    <a:p>
+                      <a:pPr algn="ctr" indent="0" marL="0">
+                        <a:lnSpc>
+                          <a:spcPts val="1680"/>
+                        </a:lnSpc>
+                        <a:buNone/>
+                      </a:pPr>
+                      <a:r>
+                        <a:rPr lang="en-US" sz="1200" dirty="0">
+                          <a:solidFill>
+                            <a:srgbClr val="2F6E9A"/>
+                          </a:solidFill>
+                          <a:latin typeface="IBM Plex Sans KR" pitchFamily="34" charset="0"/>
+                          <a:ea typeface="IBM Plex Sans KR" pitchFamily="34" charset="-122"/>
+                          <a:cs typeface="IBM Plex Sans KR" pitchFamily="34" charset="-120"/>
+                        </a:rPr>
+                        <a:t>137초</a:t>
+                      </a:r>
+                      <a:endParaRPr lang="en-US" sz="1200" dirty="0">
+                        <a:latin typeface="IBM Plex Sans KR" charset="0"/>
+                        <a:ea typeface="IBM Plex Sans KR" charset="0"/>
+                        <a:cs typeface="IBM Plex Sans KR" charset="0"/>
+                      </a:endParaRPr>
+                    </a:p>
+                  </a:txBody>
+                  <a:tcPr marL="53340" marR="53340" marT="53340" marB="53340" anchor="t">
+                    <a:lnL w="12700" cap="flat" cmpd="sng" algn="ctr">
+                      <a:solidFill>
+                        <a:srgbClr val="CBCBC8"/>
+                      </a:solidFill>
+                      <a:prstDash val="solid"/>
+                      <a:round/>
+                      <a:headEnd type="none" w="med" len="med"/>
+                      <a:tailEnd type="none" w="med" len="med"/>
+                    </a:lnL>
+                    <a:lnR w="12700" cap="flat" cmpd="sng" algn="ctr">
+                      <a:solidFill>
+                        <a:srgbClr val="CBCBC8"/>
+                      </a:solidFill>
+                      <a:prstDash val="solid"/>
+                      <a:round/>
+                      <a:headEnd type="none" w="med" len="med"/>
+                      <a:tailEnd type="none" w="med" len="med"/>
+                    </a:lnR>
+                    <a:lnT w="12700" cap="flat" cmpd="sng" algn="ctr">
+                      <a:solidFill>
+                        <a:srgbClr val="C4C4C0"/>
+                      </a:solidFill>
+                      <a:prstDash val="solid"/>
+                      <a:round/>
+                      <a:headEnd type="none" w="med" len="med"/>
+                      <a:tailEnd type="none" w="med" len="med"/>
+                    </a:lnT>
+                    <a:lnB w="12700" cap="flat" cmpd="sng" algn="ctr">
+                      <a:solidFill>
+                        <a:srgbClr val="CBCBC8"/>
+                      </a:solidFill>
+                      <a:prstDash val="solid"/>
+                      <a:round/>
+                      <a:headEnd type="none" w="med" len="med"/>
+                      <a:tailEnd type="none" w="med" len="med"/>
+                    </a:lnB>
+                    <a:solidFill>
+                      <a:srgbClr val="FFFEFB"/>
+                    </a:solidFill>
+                  </a:tcPr>
+                </a:tc>
+                <a:tc>
+                  <a:txBody>
+                    <a:bodyPr/>
+                    <a:lstStyle/>
+                    <a:p>
+                      <a:pPr algn="ctr" indent="0" marL="0">
+                        <a:lnSpc>
+                          <a:spcPts val="1680"/>
+                        </a:lnSpc>
+                        <a:buNone/>
+                      </a:pPr>
+                      <a:r>
+                        <a:rPr lang="en-US" sz="1200" dirty="0">
+                          <a:solidFill>
+                            <a:srgbClr val="2F6E9A"/>
+                          </a:solidFill>
+                          <a:latin typeface="IBM Plex Sans KR" pitchFamily="34" charset="0"/>
+                          <a:ea typeface="IBM Plex Sans KR" pitchFamily="34" charset="-122"/>
+                          <a:cs typeface="IBM Plex Sans KR" pitchFamily="34" charset="-120"/>
+                        </a:rPr>
+                        <a:t>12/12</a:t>
+                      </a:r>
+                      <a:endParaRPr lang="en-US" sz="1200" dirty="0">
+                        <a:latin typeface="IBM Plex Sans KR" charset="0"/>
+                        <a:ea typeface="IBM Plex Sans KR" charset="0"/>
+                        <a:cs typeface="IBM Plex Sans KR" charset="0"/>
+                      </a:endParaRPr>
+                    </a:p>
+                  </a:txBody>
+                  <a:tcPr marL="53340" marR="53340" marT="53340" marB="53340" anchor="t">
+                    <a:lnL w="12700" cap="flat" cmpd="sng" algn="ctr">
+                      <a:solidFill>
+                        <a:srgbClr val="CBCBC8"/>
+                      </a:solidFill>
+                      <a:prstDash val="solid"/>
+                      <a:round/>
+                      <a:headEnd type="none" w="med" len="med"/>
+                      <a:tailEnd type="none" w="med" len="med"/>
+                    </a:lnL>
+                    <a:lnR w="12700" cap="flat" cmpd="sng" algn="ctr">
+                      <a:solidFill>
+                        <a:srgbClr val="CBCBC8"/>
+                      </a:solidFill>
+                      <a:prstDash val="solid"/>
+                      <a:round/>
+                      <a:headEnd type="none" w="med" len="med"/>
+                      <a:tailEnd type="none" w="med" len="med"/>
+                    </a:lnR>
+                    <a:lnT w="12700" cap="flat" cmpd="sng" algn="ctr">
+                      <a:solidFill>
+                        <a:srgbClr val="C4C4C0"/>
+                      </a:solidFill>
+                      <a:prstDash val="solid"/>
+                      <a:round/>
+                      <a:headEnd type="none" w="med" len="med"/>
+                      <a:tailEnd type="none" w="med" len="med"/>
+                    </a:lnT>
+                    <a:lnB w="12700" cap="flat" cmpd="sng" algn="ctr">
+                      <a:solidFill>
+                        <a:srgbClr val="CBCBC8"/>
+                      </a:solidFill>
+                      <a:prstDash val="solid"/>
+                      <a:round/>
+                      <a:headEnd type="none" w="med" len="med"/>
+                      <a:tailEnd type="none" w="med" len="med"/>
+                    </a:lnB>
+                    <a:solidFill>
+                      <a:srgbClr val="FFFEFB"/>
+                    </a:solidFill>
+                  </a:tcPr>
+                </a:tc>
+                <a:tc>
+                  <a:txBody>
+                    <a:bodyPr/>
+                    <a:lstStyle/>
+                    <a:p>
+                      <a:pPr algn="ctr" indent="0" marL="0">
+                        <a:lnSpc>
+                          <a:spcPts val="1680"/>
+                        </a:lnSpc>
+                        <a:buNone/>
+                      </a:pPr>
+                      <a:r>
+                        <a:rPr lang="en-US" sz="1200" dirty="0">
+                          <a:solidFill>
+                            <a:srgbClr val="2F6E9A"/>
+                          </a:solidFill>
+                          <a:latin typeface="IBM Plex Sans KR" pitchFamily="34" charset="0"/>
+                          <a:ea typeface="IBM Plex Sans KR" pitchFamily="34" charset="-122"/>
+                          <a:cs typeface="IBM Plex Sans KR" pitchFamily="34" charset="-120"/>
+                        </a:rPr>
+                        <a:t>6.0만</a:t>
+                      </a:r>
+                      <a:endParaRPr lang="en-US" sz="1200" dirty="0">
+                        <a:latin typeface="IBM Plex Sans KR" charset="0"/>
+                        <a:ea typeface="IBM Plex Sans KR" charset="0"/>
+                        <a:cs typeface="IBM Plex Sans KR" charset="0"/>
+                      </a:endParaRPr>
+                    </a:p>
+                  </a:txBody>
+                  <a:tcPr marL="53340" marR="53340" marT="53340" marB="53340" anchor="t">
+                    <a:lnL w="12700" cap="flat" cmpd="sng" algn="ctr">
+                      <a:solidFill>
+                        <a:srgbClr val="CBCBC8"/>
+                      </a:solidFill>
+                      <a:prstDash val="solid"/>
+                      <a:round/>
+                      <a:headEnd type="none" w="med" len="med"/>
+                      <a:tailEnd type="none" w="med" len="med"/>
+                    </a:lnL>
+                    <a:lnR w="12700" cap="flat" cmpd="sng" algn="ctr">
+                      <a:solidFill>
+                        <a:srgbClr val="CBCBC8"/>
+                      </a:solidFill>
+                      <a:prstDash val="solid"/>
+                      <a:round/>
+                      <a:headEnd type="none" w="med" len="med"/>
+                      <a:tailEnd type="none" w="med" len="med"/>
+                    </a:lnR>
+                    <a:lnT w="12700" cap="flat" cmpd="sng" algn="ctr">
+                      <a:solidFill>
+                        <a:srgbClr val="C4C4C0"/>
+                      </a:solidFill>
+                      <a:prstDash val="solid"/>
+                      <a:round/>
+                      <a:headEnd type="none" w="med" len="med"/>
+                      <a:tailEnd type="none" w="med" len="med"/>
+                    </a:lnT>
+                    <a:lnB w="12700" cap="flat" cmpd="sng" algn="ctr">
+                      <a:solidFill>
+                        <a:srgbClr val="CBCBC8"/>
+                      </a:solidFill>
+                      <a:prstDash val="solid"/>
+                      <a:round/>
+                      <a:headEnd type="none" w="med" len="med"/>
+                      <a:tailEnd type="none" w="med" len="med"/>
+                    </a:lnB>
+                    <a:solidFill>
+                      <a:srgbClr val="FFFEFB"/>
+                    </a:solidFill>
+                  </a:tcPr>
+                </a:tc>
+              </a:tr>
+            </a:tbl>
+          </a:graphicData>
+        </a:graphic>
+      </p:graphicFrame>
+      <p:sp>
+        <p:nvSpPr>
+          <p:cNvPr id="5" name="Shape 2"/>
           <p:cNvSpPr/>
           <p:nvPr/>
         </p:nvSpPr>
         <p:spPr>
           <a:xfrm>
-            <a:off x="815975" y="1801416"/>
-            <a:ext cx="5200650" cy="1591370"/>
+            <a:off x="812800" y="3789263"/>
+            <a:ext cx="6756400" cy="972741"/>
           </a:xfrm>
           <a:prstGeom prst="roundRect">
             <a:avLst>
-              <a:gd name="adj" fmla="val 7781"/>
+              <a:gd name="adj" fmla="val 10445"/>
             </a:avLst>
           </a:prstGeom>
           <a:solidFill>
-            <a:srgbClr val="FFFEFB"/>
-          </a:solidFill>
-          <a:ln w="6350">
-            <a:solidFill>
-              <a:srgbClr val="DCD8CF"/>
-            </a:solidFill>
-            <a:prstDash val="solid"/>
-          </a:ln>
-        </p:spPr>
-      </p:sp>
-      <p:sp>
-        <p:nvSpPr>
-          <p:cNvPr id="5" name="Shape 3"/>
-          <p:cNvSpPr/>
-          <p:nvPr/>
-        </p:nvSpPr>
-        <p:spPr>
-          <a:xfrm>
-            <a:off x="1022350" y="1969691"/>
-            <a:ext cx="457200" cy="457200"/>
-          </a:xfrm>
-          <a:prstGeom prst="roundRect">
-            <a:avLst>
-              <a:gd name="adj" fmla="val 50000"/>
-            </a:avLst>
-          </a:prstGeom>
-          <a:solidFill>
-            <a:srgbClr val="F3E2CC"/>
+            <a:srgbClr val="1C2430"/>
           </a:solidFill>
           <a:ln/>
         </p:spPr>
       </p:sp>
-      <p:pic>
-        <p:nvPicPr>
-          <p:cNvPr id="6" name="Image 0" descr="Wrench">    </p:cNvPr>
-          <p:cNvPicPr>
-            <a:picLocks noChangeAspect="1"/>
-          </p:cNvPicPr>
+      <p:sp>
+        <p:nvSpPr>
+          <p:cNvPr id="6" name="Text 3"/>
+          <p:cNvSpPr/>
           <p:nvPr/>
-        </p:nvPicPr>
-        <p:blipFill>
-          <a:blip r:embed="rId1"/>
-          <a:srcRect l="0" r="0" t="0" b="0"/>
-          <a:stretch/>
-        </p:blipFill>
-        <p:spPr>
-          <a:xfrm>
-            <a:off x="1123950" y="2071291"/>
-            <a:ext cx="254000" cy="254000"/>
-          </a:xfrm>
-          <a:prstGeom prst="rect">
-            <a:avLst/>
-          </a:prstGeom>
-        </p:spPr>
-      </p:pic>
-      <p:sp>
-        <p:nvSpPr>
-          <p:cNvPr id="7" name="Text 4"/>
-          <p:cNvSpPr/>
-          <p:nvPr/>
-        </p:nvSpPr>
-        <p:spPr>
-          <a:xfrm>
-            <a:off x="1631950" y="1969691"/>
-            <a:ext cx="4303649" cy="269230"/>
+        </p:nvSpPr>
+        <p:spPr>
+          <a:xfrm>
+            <a:off x="990600" y="3928963"/>
+            <a:ext cx="6592824" cy="238720"/>
           </a:xfrm>
           <a:prstGeom prst="rect">
             <a:avLst/>
@@ -8328,35 +10089,35 @@
           <a:p>
             <a:pPr algn="l" indent="0" marL="0">
               <a:lnSpc>
-                <a:spcPts val="1920"/>
+                <a:spcPts val="1680"/>
               </a:lnSpc>
               <a:buNone/>
             </a:pPr>
             <a:r>
-              <a:rPr lang="en-US" sz="1600" b="1" dirty="0">
+              <a:rPr lang="en-US" sz="1200" b="1" dirty="0">
                 <a:solidFill>
-                  <a:srgbClr val="1C2430"/>
+                  <a:srgbClr val="E9A54A"/>
                 </a:solidFill>
                 <a:latin typeface="IBM Plex Sans KR" pitchFamily="34" charset="0"/>
                 <a:ea typeface="IBM Plex Sans KR" pitchFamily="34" charset="-122"/>
                 <a:cs typeface="IBM Plex Sans KR" pitchFamily="34" charset="-120"/>
               </a:rPr>
-              <a:t>재제조·정비 라인</a:t>
+              <a:t>한 번 드는 비용</a:t>
             </a:r>
-            <a:endParaRPr lang="en-US" sz="1600" dirty="0"/>
+            <a:endParaRPr lang="en-US" sz="1200" dirty="0"/>
           </a:p>
         </p:txBody>
       </p:sp>
       <p:sp>
         <p:nvSpPr>
-          <p:cNvPr id="8" name="Text 5"/>
+          <p:cNvPr id="7" name="Text 4"/>
           <p:cNvSpPr/>
           <p:nvPr/>
         </p:nvSpPr>
         <p:spPr>
           <a:xfrm>
-            <a:off x="1631950" y="2264321"/>
-            <a:ext cx="4303649" cy="467320"/>
+            <a:off x="990600" y="4180384"/>
+            <a:ext cx="6592824" cy="467320"/>
           </a:xfrm>
           <a:prstGeom prst="rect">
             <a:avLst/>
@@ -8379,13 +10140,13 @@
             <a:r>
               <a:rPr lang="en-US" sz="1200" dirty="0">
                 <a:solidFill>
-                  <a:srgbClr val="4A5560"/>
+                  <a:srgbClr val="F2EFE8"/>
                 </a:solidFill>
                 <a:latin typeface="IBM Plex Sans KR" pitchFamily="34" charset="0"/>
                 <a:ea typeface="IBM Plex Sans KR" pitchFamily="34" charset="-122"/>
                 <a:cs typeface="IBM Plex Sans KR" pitchFamily="34" charset="-120"/>
               </a:rPr>
-              <a:t>같은 제품군이 반복 입고되는 현장에서 조립체별 SKILL.md를 쌓아, 두 번째부터 최소 시도로 분해 순서를 제시</a:t>
+              <a:t>조립체별 SKILL.md 작성 = 모델 호출 1회(약 1.6만 토큰), 물리 시도 0회. 재료인 1차 기록은 원래 하던 분해에서 나옵니다</a:t>
             </a:r>
             <a:endParaRPr lang="en-US" sz="1200" dirty="0"/>
           </a:p>
@@ -8393,130 +10154,14 @@
       </p:sp>
       <p:sp>
         <p:nvSpPr>
-          <p:cNvPr id="9" name="Shape 6"/>
+          <p:cNvPr id="8" name="Text 5"/>
           <p:cNvSpPr/>
           <p:nvPr/>
         </p:nvSpPr>
         <p:spPr>
           <a:xfrm>
-            <a:off x="6175375" y="1801416"/>
-            <a:ext cx="5200650" cy="1591370"/>
-          </a:xfrm>
-          <a:prstGeom prst="roundRect">
-            <a:avLst>
-              <a:gd name="adj" fmla="val 7781"/>
-            </a:avLst>
-          </a:prstGeom>
-          <a:solidFill>
-            <a:srgbClr val="FFFEFB"/>
-          </a:solidFill>
-          <a:ln w="6350">
-            <a:solidFill>
-              <a:srgbClr val="DCD8CF"/>
-            </a:solidFill>
-            <a:prstDash val="solid"/>
-          </a:ln>
-        </p:spPr>
-      </p:sp>
-      <p:sp>
-        <p:nvSpPr>
-          <p:cNvPr id="10" name="Shape 7"/>
-          <p:cNvSpPr/>
-          <p:nvPr/>
-        </p:nvSpPr>
-        <p:spPr>
-          <a:xfrm>
-            <a:off x="6381750" y="1969691"/>
-            <a:ext cx="457200" cy="457200"/>
-          </a:xfrm>
-          <a:prstGeom prst="roundRect">
-            <a:avLst>
-              <a:gd name="adj" fmla="val 50000"/>
-            </a:avLst>
-          </a:prstGeom>
-          <a:solidFill>
-            <a:srgbClr val="F3E2CC"/>
-          </a:solidFill>
-          <a:ln/>
-        </p:spPr>
-      </p:sp>
-      <p:pic>
-        <p:nvPicPr>
-          <p:cNvPr id="11" name="Image 1" descr="Book">    </p:cNvPr>
-          <p:cNvPicPr>
-            <a:picLocks noChangeAspect="1"/>
-          </p:cNvPicPr>
-          <p:nvPr/>
-        </p:nvPicPr>
-        <p:blipFill>
-          <a:blip r:embed="rId2"/>
-          <a:srcRect l="0" r="0" t="0" b="0"/>
-          <a:stretch/>
-        </p:blipFill>
-        <p:spPr>
-          <a:xfrm>
-            <a:off x="6483350" y="2071291"/>
-            <a:ext cx="254000" cy="254000"/>
-          </a:xfrm>
-          <a:prstGeom prst="rect">
-            <a:avLst/>
-          </a:prstGeom>
-        </p:spPr>
-      </p:pic>
-      <p:sp>
-        <p:nvSpPr>
-          <p:cNvPr id="12" name="Text 8"/>
-          <p:cNvSpPr/>
-          <p:nvPr/>
-        </p:nvSpPr>
-        <p:spPr>
-          <a:xfrm>
-            <a:off x="6991350" y="1969691"/>
-            <a:ext cx="4303649" cy="269230"/>
-          </a:xfrm>
-          <a:prstGeom prst="rect">
-            <a:avLst/>
-          </a:prstGeom>
-          <a:noFill/>
-          <a:ln/>
-        </p:spPr>
-        <p:txBody>
-          <a:bodyPr wrap="square" lIns="0" tIns="0" rIns="0" bIns="0" rtlCol="0" anchor="t">
-            <a:normAutofit/>
-          </a:bodyPr>
-          <a:lstStyle/>
-          <a:p>
-            <a:pPr algn="l" indent="0" marL="0">
-              <a:lnSpc>
-                <a:spcPts val="1920"/>
-              </a:lnSpc>
-              <a:buNone/>
-            </a:pPr>
-            <a:r>
-              <a:rPr lang="en-US" sz="1600" b="1" dirty="0">
-                <a:solidFill>
-                  <a:srgbClr val="1C2430"/>
-                </a:solidFill>
-                <a:latin typeface="IBM Plex Sans KR" pitchFamily="34" charset="0"/>
-                <a:ea typeface="IBM Plex Sans KR" pitchFamily="34" charset="-122"/>
-                <a:cs typeface="IBM Plex Sans KR" pitchFamily="34" charset="-120"/>
-              </a:rPr>
-              <a:t>검수 가능한 작업 지식</a:t>
-            </a:r>
-            <a:endParaRPr lang="en-US" sz="1600" dirty="0"/>
-          </a:p>
-        </p:txBody>
-      </p:sp>
-      <p:sp>
-        <p:nvSpPr>
-          <p:cNvPr id="13" name="Text 9"/>
-          <p:cNvSpPr/>
-          <p:nvPr/>
-        </p:nvSpPr>
-        <p:spPr>
-          <a:xfrm>
-            <a:off x="6991350" y="2264321"/>
-            <a:ext cx="4303649" cy="467320"/>
+            <a:off x="812800" y="4889004"/>
+            <a:ext cx="6959092" cy="467320"/>
           </a:xfrm>
           <a:prstGeom prst="rect">
             <a:avLst/>
@@ -8537,15 +10182,26 @@
               <a:buNone/>
             </a:pPr>
             <a:r>
-              <a:rPr lang="en-US" sz="1200" dirty="0">
+              <a:rPr lang="en-US" sz="1200" b="1" dirty="0">
                 <a:solidFill>
-                  <a:srgbClr val="4A5560"/>
+                  <a:srgbClr val="3E4A57"/>
                 </a:solidFill>
                 <a:latin typeface="IBM Plex Sans KR" pitchFamily="34" charset="0"/>
                 <a:ea typeface="IBM Plex Sans KR" pitchFamily="34" charset="-122"/>
                 <a:cs typeface="IBM Plex Sans KR" pitchFamily="34" charset="-120"/>
               </a:rPr>
-              <a:t>SKILL.md는 사람이 읽고 고치고 승인할 수 있으므로 작업 표준서, 안전 규칙과 함께 관리</a:t>
+              <a:t>본전 시점</a:t>
+            </a:r>
+            <a:r>
+              <a:rPr lang="en-US" sz="1200" dirty="0">
+                <a:solidFill>
+                  <a:srgbClr val="3E4A57"/>
+                </a:solidFill>
+                <a:latin typeface="IBM Plex Sans KR" pitchFamily="34" charset="0"/>
+                <a:ea typeface="IBM Plex Sans KR" pitchFamily="34" charset="-122"/>
+                <a:cs typeface="IBM Plex Sans KR" pitchFamily="34" charset="-120"/>
+              </a:rPr>
+              <a:t> 실패 시도와 시간은 첫 재방문부터 줄어듭니다. 토큰은 C가 회당 약 3.1만 줄어 첫 재방문에 회수, B는 거의 같습니다.</a:t>
             </a:r>
             <a:endParaRPr lang="en-US" sz="1200" dirty="0"/>
           </a:p>
@@ -8553,18 +10209,18 @@
       </p:sp>
       <p:sp>
         <p:nvSpPr>
-          <p:cNvPr id="14" name="Shape 10"/>
+          <p:cNvPr id="9" name="Shape 6"/>
           <p:cNvSpPr/>
           <p:nvPr/>
         </p:nvSpPr>
         <p:spPr>
           <a:xfrm>
-            <a:off x="815975" y="3551535"/>
-            <a:ext cx="5200650" cy="1591370"/>
+            <a:off x="7826375" y="1776016"/>
+            <a:ext cx="3549650" cy="976511"/>
           </a:xfrm>
           <a:prstGeom prst="roundRect">
             <a:avLst>
-              <a:gd name="adj" fmla="val 7781"/>
+              <a:gd name="adj" fmla="val 10079"/>
             </a:avLst>
           </a:prstGeom>
           <a:solidFill>
@@ -8580,59 +10236,14 @@
       </p:sp>
       <p:sp>
         <p:nvSpPr>
-          <p:cNvPr id="15" name="Shape 11"/>
+          <p:cNvPr id="10" name="Text 7"/>
           <p:cNvSpPr/>
           <p:nvPr/>
         </p:nvSpPr>
         <p:spPr>
           <a:xfrm>
-            <a:off x="1022350" y="3719810"/>
-            <a:ext cx="457200" cy="457200"/>
-          </a:xfrm>
-          <a:prstGeom prst="roundRect">
-            <a:avLst>
-              <a:gd name="adj" fmla="val 50000"/>
-            </a:avLst>
-          </a:prstGeom>
-          <a:solidFill>
-            <a:srgbClr val="F3E2CC"/>
-          </a:solidFill>
-          <a:ln/>
-        </p:spPr>
-      </p:sp>
-      <p:pic>
-        <p:nvPicPr>
-          <p:cNvPr id="16" name="Image 2" descr="Search">    </p:cNvPr>
-          <p:cNvPicPr>
-            <a:picLocks noChangeAspect="1"/>
-          </p:cNvPicPr>
-          <p:nvPr/>
-        </p:nvPicPr>
-        <p:blipFill>
-          <a:blip r:embed="rId3"/>
-          <a:srcRect l="0" r="0" t="0" b="0"/>
-          <a:stretch/>
-        </p:blipFill>
-        <p:spPr>
-          <a:xfrm>
-            <a:off x="1123950" y="3821410"/>
-            <a:ext cx="254000" cy="254000"/>
-          </a:xfrm>
-          <a:prstGeom prst="rect">
-            <a:avLst/>
-          </a:prstGeom>
-        </p:spPr>
-      </p:pic>
-      <p:sp>
-        <p:nvSpPr>
-          <p:cNvPr id="17" name="Text 12"/>
-          <p:cNvSpPr/>
-          <p:nvPr/>
-        </p:nvSpPr>
-        <p:spPr>
-          <a:xfrm>
-            <a:off x="1631950" y="3719810"/>
-            <a:ext cx="4303649" cy="269230"/>
+            <a:off x="8007350" y="1918891"/>
+            <a:ext cx="3283331" cy="238720"/>
           </a:xfrm>
           <a:prstGeom prst="rect">
             <a:avLst/>
@@ -8648,12 +10259,12 @@
           <a:p>
             <a:pPr algn="l" indent="0" marL="0">
               <a:lnSpc>
-                <a:spcPts val="1920"/>
+                <a:spcPts val="1680"/>
               </a:lnSpc>
               <a:buNone/>
             </a:pPr>
             <a:r>
-              <a:rPr lang="en-US" sz="1600" b="1" dirty="0">
+              <a:rPr lang="en-US" sz="1400" b="1" dirty="0">
                 <a:solidFill>
                   <a:srgbClr val="1C2430"/>
                 </a:solidFill>
@@ -8661,22 +10272,22 @@
                 <a:ea typeface="IBM Plex Sans KR" pitchFamily="34" charset="-122"/>
                 <a:cs typeface="IBM Plex Sans KR" pitchFamily="34" charset="-120"/>
               </a:rPr>
-              <a:t>신제품 사전 검토</a:t>
+              <a:t>재제조·정비 라인</a:t>
             </a:r>
-            <a:endParaRPr lang="en-US" sz="1600" dirty="0"/>
+            <a:endParaRPr lang="en-US" sz="1400" dirty="0"/>
           </a:p>
         </p:txBody>
       </p:sp>
       <p:sp>
         <p:nvSpPr>
-          <p:cNvPr id="18" name="Text 13"/>
+          <p:cNvPr id="11" name="Text 8"/>
           <p:cNvSpPr/>
           <p:nvPr/>
         </p:nvSpPr>
         <p:spPr>
           <a:xfrm>
-            <a:off x="1631950" y="4014440"/>
-            <a:ext cx="4303649" cy="467320"/>
+            <a:off x="8007350" y="2183011"/>
+            <a:ext cx="3283331" cy="452041"/>
           </a:xfrm>
           <a:prstGeom prst="rect">
             <a:avLst/>
@@ -8686,6 +10297,169 @@
         </p:spPr>
         <p:txBody>
           <a:bodyPr wrap="square" lIns="0" tIns="0" rIns="0" bIns="0" rtlCol="0" anchor="t">
+            <a:normAutofit/>
+          </a:bodyPr>
+          <a:lstStyle/>
+          <a:p>
+            <a:pPr algn="l" indent="0" marL="0">
+              <a:lnSpc>
+                <a:spcPts val="1680"/>
+              </a:lnSpc>
+              <a:buNone/>
+            </a:pPr>
+            <a:r>
+              <a:rPr lang="en-US" sz="1200" dirty="0">
+                <a:solidFill>
+                  <a:srgbClr val="4A5560"/>
+                </a:solidFill>
+                <a:latin typeface="IBM Plex Sans KR" pitchFamily="34" charset="0"/>
+                <a:ea typeface="IBM Plex Sans KR" pitchFamily="34" charset="-122"/>
+                <a:cs typeface="IBM Plex Sans KR" pitchFamily="34" charset="-120"/>
+              </a:rPr>
+              <a:t>반복 입고되는 제품마다 조립체별 SKILL.md를 쌓아, 두 번째부터 실패 없는 분해 순서를 제시</a:t>
+            </a:r>
+            <a:endParaRPr lang="en-US" sz="1200" dirty="0"/>
+          </a:p>
+        </p:txBody>
+      </p:sp>
+      <p:sp>
+        <p:nvSpPr>
+          <p:cNvPr id="12" name="Shape 9"/>
+          <p:cNvSpPr/>
+          <p:nvPr/>
+        </p:nvSpPr>
+        <p:spPr>
+          <a:xfrm>
+            <a:off x="7826375" y="2885877"/>
+            <a:ext cx="3549650" cy="976511"/>
+          </a:xfrm>
+          <a:prstGeom prst="roundRect">
+            <a:avLst>
+              <a:gd name="adj" fmla="val 10079"/>
+            </a:avLst>
+          </a:prstGeom>
+          <a:solidFill>
+            <a:srgbClr val="FFFEFB"/>
+          </a:solidFill>
+          <a:ln w="6350">
+            <a:solidFill>
+              <a:srgbClr val="DCD8CF"/>
+            </a:solidFill>
+            <a:prstDash val="solid"/>
+          </a:ln>
+        </p:spPr>
+      </p:sp>
+      <p:sp>
+        <p:nvSpPr>
+          <p:cNvPr id="13" name="Text 10"/>
+          <p:cNvSpPr/>
+          <p:nvPr/>
+        </p:nvSpPr>
+        <p:spPr>
+          <a:xfrm>
+            <a:off x="8007350" y="3028752"/>
+            <a:ext cx="3283331" cy="238720"/>
+          </a:xfrm>
+          <a:prstGeom prst="rect">
+            <a:avLst/>
+          </a:prstGeom>
+          <a:noFill/>
+          <a:ln/>
+        </p:spPr>
+        <p:txBody>
+          <a:bodyPr wrap="square" lIns="0" tIns="0" rIns="0" bIns="0" rtlCol="0" anchor="t">
+            <a:normAutofit/>
+          </a:bodyPr>
+          <a:lstStyle/>
+          <a:p>
+            <a:pPr algn="l" indent="0" marL="0">
+              <a:lnSpc>
+                <a:spcPts val="1680"/>
+              </a:lnSpc>
+              <a:buNone/>
+            </a:pPr>
+            <a:r>
+              <a:rPr lang="en-US" sz="1400" b="1" dirty="0">
+                <a:solidFill>
+                  <a:srgbClr val="1C2430"/>
+                </a:solidFill>
+                <a:latin typeface="IBM Plex Sans KR" pitchFamily="34" charset="0"/>
+                <a:ea typeface="IBM Plex Sans KR" pitchFamily="34" charset="-122"/>
+                <a:cs typeface="IBM Plex Sans KR" pitchFamily="34" charset="-120"/>
+              </a:rPr>
+              <a:t>검수 가능한 작업 지식</a:t>
+            </a:r>
+            <a:endParaRPr lang="en-US" sz="1400" dirty="0"/>
+          </a:p>
+        </p:txBody>
+      </p:sp>
+      <p:sp>
+        <p:nvSpPr>
+          <p:cNvPr id="14" name="Text 11"/>
+          <p:cNvSpPr/>
+          <p:nvPr/>
+        </p:nvSpPr>
+        <p:spPr>
+          <a:xfrm>
+            <a:off x="8007350" y="3292872"/>
+            <a:ext cx="3283331" cy="452041"/>
+          </a:xfrm>
+          <a:prstGeom prst="rect">
+            <a:avLst/>
+          </a:prstGeom>
+          <a:noFill/>
+          <a:ln/>
+        </p:spPr>
+        <p:txBody>
+          <a:bodyPr wrap="square" lIns="0" tIns="0" rIns="0" bIns="0" rtlCol="0" anchor="t">
+            <a:normAutofit/>
+          </a:bodyPr>
+          <a:lstStyle/>
+          <a:p>
+            <a:pPr algn="l" indent="0" marL="0">
+              <a:lnSpc>
+                <a:spcPts val="1680"/>
+              </a:lnSpc>
+              <a:buNone/>
+            </a:pPr>
+            <a:r>
+              <a:rPr lang="en-US" sz="1200" dirty="0">
+                <a:solidFill>
+                  <a:srgbClr val="4A5560"/>
+                </a:solidFill>
+                <a:latin typeface="IBM Plex Sans KR" pitchFamily="34" charset="0"/>
+                <a:ea typeface="IBM Plex Sans KR" pitchFamily="34" charset="-122"/>
+                <a:cs typeface="IBM Plex Sans KR" pitchFamily="34" charset="-120"/>
+              </a:rPr>
+              <a:t>사람이 읽고 고치고 승인할 수 있는 파일이라 작업 표준서·안전 규칙과 함께 관리</a:t>
+            </a:r>
+            <a:endParaRPr lang="en-US" sz="1200" dirty="0"/>
+          </a:p>
+        </p:txBody>
+      </p:sp>
+      <p:sp>
+        <p:nvSpPr>
+          <p:cNvPr id="15" name="Text 12"/>
+          <p:cNvSpPr/>
+          <p:nvPr/>
+        </p:nvSpPr>
+        <p:spPr>
+          <a:xfrm>
+            <a:off x="7823200" y="3992563"/>
+            <a:ext cx="3556000" cy="916880"/>
+          </a:xfrm>
+          <a:prstGeom prst="roundRect">
+            <a:avLst>
+              <a:gd name="adj" fmla="val 11081"/>
+            </a:avLst>
+          </a:prstGeom>
+          <a:solidFill>
+            <a:srgbClr val="F3E2CC"/>
+          </a:solidFill>
+          <a:ln/>
+        </p:spPr>
+        <p:txBody>
+          <a:bodyPr wrap="square" lIns="135342" tIns="97242" rIns="38568" bIns="71842" rtlCol="0" anchor="t">
             <a:normAutofit/>
           </a:bodyPr>
           <a:lstStyle/>
@@ -8699,221 +10473,13 @@
             <a:r>
               <a:rPr lang="en-US" sz="1200" dirty="0">
                 <a:solidFill>
-                  <a:srgbClr val="4A5560"/>
-                </a:solidFill>
-                <a:latin typeface="IBM Plex Sans KR" pitchFamily="34" charset="0"/>
-                <a:ea typeface="IBM Plex Sans KR" pitchFamily="34" charset="-122"/>
-                <a:cs typeface="IBM Plex Sans KR" pitchFamily="34" charset="-120"/>
-              </a:rPr>
-              <a:t>설계 단계에서 분해 가능성과 막히는 부품을 시뮬레이션으로 먼저 확인 (분해·재활용을 고려한 설계)</a:t>
-            </a:r>
-            <a:endParaRPr lang="en-US" sz="1200" dirty="0"/>
-          </a:p>
-        </p:txBody>
-      </p:sp>
-      <p:sp>
-        <p:nvSpPr>
-          <p:cNvPr id="19" name="Shape 14"/>
-          <p:cNvSpPr/>
-          <p:nvPr/>
-        </p:nvSpPr>
-        <p:spPr>
-          <a:xfrm>
-            <a:off x="6175375" y="3551535"/>
-            <a:ext cx="5200650" cy="1591370"/>
-          </a:xfrm>
-          <a:prstGeom prst="roundRect">
-            <a:avLst>
-              <a:gd name="adj" fmla="val 7781"/>
-            </a:avLst>
-          </a:prstGeom>
-          <a:solidFill>
-            <a:srgbClr val="FFFEFB"/>
-          </a:solidFill>
-          <a:ln w="6350">
-            <a:solidFill>
-              <a:srgbClr val="DCD8CF"/>
-            </a:solidFill>
-            <a:prstDash val="solid"/>
-          </a:ln>
-        </p:spPr>
-      </p:sp>
-      <p:sp>
-        <p:nvSpPr>
-          <p:cNvPr id="20" name="Shape 15"/>
-          <p:cNvSpPr/>
-          <p:nvPr/>
-        </p:nvSpPr>
-        <p:spPr>
-          <a:xfrm>
-            <a:off x="6381750" y="3719810"/>
-            <a:ext cx="457200" cy="457200"/>
-          </a:xfrm>
-          <a:prstGeom prst="roundRect">
-            <a:avLst>
-              <a:gd name="adj" fmla="val 50000"/>
-            </a:avLst>
-          </a:prstGeom>
-          <a:solidFill>
-            <a:srgbClr val="F3E2CC"/>
-          </a:solidFill>
-          <a:ln/>
-        </p:spPr>
-      </p:sp>
-      <p:pic>
-        <p:nvPicPr>
-          <p:cNvPr id="21" name="Image 3" descr="Database">    </p:cNvPr>
-          <p:cNvPicPr>
-            <a:picLocks noChangeAspect="1"/>
-          </p:cNvPicPr>
-          <p:nvPr/>
-        </p:nvPicPr>
-        <p:blipFill>
-          <a:blip r:embed="rId4"/>
-          <a:srcRect l="0" r="0" t="0" b="0"/>
-          <a:stretch/>
-        </p:blipFill>
-        <p:spPr>
-          <a:xfrm>
-            <a:off x="6483350" y="3821410"/>
-            <a:ext cx="254000" cy="254000"/>
-          </a:xfrm>
-          <a:prstGeom prst="rect">
-            <a:avLst/>
-          </a:prstGeom>
-        </p:spPr>
-      </p:pic>
-      <p:sp>
-        <p:nvSpPr>
-          <p:cNvPr id="22" name="Text 16"/>
-          <p:cNvSpPr/>
-          <p:nvPr/>
-        </p:nvSpPr>
-        <p:spPr>
-          <a:xfrm>
-            <a:off x="6991350" y="3719810"/>
-            <a:ext cx="4303649" cy="269230"/>
-          </a:xfrm>
-          <a:prstGeom prst="rect">
-            <a:avLst/>
-          </a:prstGeom>
-          <a:noFill/>
-          <a:ln/>
-        </p:spPr>
-        <p:txBody>
-          <a:bodyPr wrap="square" lIns="0" tIns="0" rIns="0" bIns="0" rtlCol="0" anchor="t">
-            <a:normAutofit/>
-          </a:bodyPr>
-          <a:lstStyle/>
-          <a:p>
-            <a:pPr algn="l" indent="0" marL="0">
-              <a:lnSpc>
-                <a:spcPts val="1920"/>
-              </a:lnSpc>
-              <a:buNone/>
-            </a:pPr>
-            <a:r>
-              <a:rPr lang="en-US" sz="1600" b="1" dirty="0">
-                <a:solidFill>
-                  <a:srgbClr val="1C2430"/>
-                </a:solidFill>
-                <a:latin typeface="IBM Plex Sans KR" pitchFamily="34" charset="0"/>
-                <a:ea typeface="IBM Plex Sans KR" pitchFamily="34" charset="-122"/>
-                <a:cs typeface="IBM Plex Sans KR" pitchFamily="34" charset="-120"/>
-              </a:rPr>
-              <a:t>SKILL.md 축적과 일반화</a:t>
-            </a:r>
-            <a:endParaRPr lang="en-US" sz="1600" dirty="0"/>
-          </a:p>
-        </p:txBody>
-      </p:sp>
-      <p:sp>
-        <p:nvSpPr>
-          <p:cNvPr id="23" name="Text 17"/>
-          <p:cNvSpPr/>
-          <p:nvPr/>
-        </p:nvSpPr>
-        <p:spPr>
-          <a:xfrm>
-            <a:off x="6991350" y="4014440"/>
-            <a:ext cx="4303649" cy="467320"/>
-          </a:xfrm>
-          <a:prstGeom prst="rect">
-            <a:avLst/>
-          </a:prstGeom>
-          <a:noFill/>
-          <a:ln/>
-        </p:spPr>
-        <p:txBody>
-          <a:bodyPr wrap="square" lIns="0" tIns="0" rIns="0" bIns="0" rtlCol="0" anchor="t">
-            <a:normAutofit/>
-          </a:bodyPr>
-          <a:lstStyle/>
-          <a:p>
-            <a:pPr algn="l" indent="0" marL="0">
-              <a:lnSpc>
-                <a:spcPts val="1740"/>
-              </a:lnSpc>
-              <a:buNone/>
-            </a:pPr>
-            <a:r>
-              <a:rPr lang="en-US" sz="1200" dirty="0">
-                <a:solidFill>
-                  <a:srgbClr val="4A5560"/>
-                </a:solidFill>
-                <a:latin typeface="IBM Plex Sans KR" pitchFamily="34" charset="0"/>
-                <a:ea typeface="IBM Plex Sans KR" pitchFamily="34" charset="-122"/>
-                <a:cs typeface="IBM Plex Sans KR" pitchFamily="34" charset="-120"/>
-              </a:rPr>
-              <a:t>조립체별 SKILL.md를 모아 두고, 여러 제품에서 반복되는 패턴만 검증을 거쳐 범용 SKILL.md로 정리</a:t>
-            </a:r>
-            <a:endParaRPr lang="en-US" sz="1200" dirty="0"/>
-          </a:p>
-        </p:txBody>
-      </p:sp>
-      <p:sp>
-        <p:nvSpPr>
-          <p:cNvPr id="24" name="Text 18"/>
-          <p:cNvSpPr/>
-          <p:nvPr/>
-        </p:nvSpPr>
-        <p:spPr>
-          <a:xfrm>
-            <a:off x="812800" y="5374680"/>
-            <a:ext cx="10566400" cy="467320"/>
-          </a:xfrm>
-          <a:prstGeom prst="roundRect">
-            <a:avLst>
-              <a:gd name="adj" fmla="val 19023"/>
-            </a:avLst>
-          </a:prstGeom>
-          <a:solidFill>
-            <a:srgbClr val="F3E2CC"/>
-          </a:solidFill>
-          <a:ln/>
-        </p:spPr>
-        <p:txBody>
-          <a:bodyPr wrap="square" lIns="151762" tIns="100962" rIns="0" bIns="75562" rtlCol="0" anchor="t">
-            <a:normAutofit/>
-          </a:bodyPr>
-          <a:lstStyle/>
-          <a:p>
-            <a:pPr algn="l" indent="0" marL="0">
-              <a:lnSpc>
-                <a:spcPts val="1680"/>
-              </a:lnSpc>
-              <a:buNone/>
-            </a:pPr>
-            <a:r>
-              <a:rPr lang="en-US" sz="1200" dirty="0">
-                <a:solidFill>
                   <a:srgbClr val="3E4A57"/>
                 </a:solidFill>
                 <a:latin typeface="IBM Plex Sans KR" pitchFamily="34" charset="0"/>
                 <a:ea typeface="IBM Plex Sans KR" pitchFamily="34" charset="-122"/>
                 <a:cs typeface="IBM Plex Sans KR" pitchFamily="34" charset="-120"/>
               </a:rPr>
-              <a:t>이 장의 내용은 실험으로 검증하지 않은 제안입니다. 실제 로봇 제어, 그리퍼, 힘 기반 분해는 후속 과제입니다.</a:t>
+              <a:t>현장 적용은 실험으로 검증하지 않은 제안입니다. 모델 단가를 확인하지 못해 금액으로는 환산하지 않았습니다.</a:t>
             </a:r>
             <a:endParaRPr lang="en-US" sz="1200" dirty="0"/>
           </a:p>
@@ -8921,7 +10487,7 @@
       </p:sp>
       <p:sp>
         <p:nvSpPr>
-          <p:cNvPr id="25" name="Text 19"/>
+          <p:cNvPr id="16" name="Text 13"/>
           <p:cNvSpPr/>
           <p:nvPr/>
         </p:nvSpPr>
@@ -8957,7 +10523,7 @@
                 <a:ea typeface="IBM Plex Sans KR" pitchFamily="34" charset="-122"/>
                 <a:cs typeface="IBM Plex Sans KR" pitchFamily="34" charset="-120"/>
               </a:rPr>
-              <a:t>SKILL.md 기반 Disassembly Planner · 13</a:t>
+              <a:t>SKILL.md 기반 Disassembly Planner · 13 · 평가 CAD 4개 평균, 900초 시간 초과 포함(없음: B·C 각 1회) · 있음 = S3·S5 분기 합산</a:t>
             </a:r>
             <a:endParaRPr lang="en-US" sz="1200" dirty="0"/>
           </a:p>
@@ -9101,7 +10667,7 @@
         </p:nvGraphicFramePr>
         <p:xfrm>
           <a:off x="825500" y="1836341"/>
-          <a:ext cx="10553700" cy="3105696"/>
+          <a:ext cx="10553700" cy="3465016"/>
         </p:xfrm>
         <a:graphic>
           <a:graphicData uri="http://schemas.openxmlformats.org/drawingml/2006/table">
@@ -9696,6 +11262,150 @@
                           <a:ea typeface="IBM Plex Sans KR" pitchFamily="34" charset="-122"/>
                           <a:cs typeface="IBM Plex Sans KR" pitchFamily="34" charset="-120"/>
                         </a:rPr>
+                        <a:t>경로 재생 대조 없음</a:t>
+                      </a:r>
+                      <a:endParaRPr lang="en-US" sz="1300" dirty="0">
+                        <a:latin typeface="IBM Plex Sans KR" charset="0"/>
+                        <a:ea typeface="IBM Plex Sans KR" charset="0"/>
+                        <a:cs typeface="IBM Plex Sans KR" charset="0"/>
+                      </a:endParaRPr>
+                    </a:p>
+                  </a:txBody>
+                  <a:tcPr marL="57785" marR="57785" marT="57785" marB="57785" anchor="t">
+                    <a:lnL w="12700" cap="flat" cmpd="sng" algn="ctr">
+                      <a:solidFill>
+                        <a:srgbClr val="C4C4C0"/>
+                      </a:solidFill>
+                      <a:prstDash val="solid"/>
+                      <a:round/>
+                      <a:headEnd type="none" w="med" len="med"/>
+                      <a:tailEnd type="none" w="med" len="med"/>
+                    </a:lnL>
+                    <a:lnR w="12700" cap="flat" cmpd="sng" algn="ctr">
+                      <a:solidFill>
+                        <a:srgbClr val="CBCBC8"/>
+                      </a:solidFill>
+                      <a:prstDash val="solid"/>
+                      <a:round/>
+                      <a:headEnd type="none" w="med" len="med"/>
+                      <a:tailEnd type="none" w="med" len="med"/>
+                    </a:lnR>
+                    <a:lnT w="12700" cap="flat" cmpd="sng" algn="ctr">
+                      <a:solidFill>
+                        <a:srgbClr val="C4C4C0"/>
+                      </a:solidFill>
+                      <a:prstDash val="solid"/>
+                      <a:round/>
+                      <a:headEnd type="none" w="med" len="med"/>
+                      <a:tailEnd type="none" w="med" len="med"/>
+                    </a:lnT>
+                    <a:lnB w="12700" cap="flat" cmpd="sng" algn="ctr">
+                      <a:solidFill>
+                        <a:srgbClr val="CBCBC8"/>
+                      </a:solidFill>
+                      <a:prstDash val="solid"/>
+                      <a:round/>
+                      <a:headEnd type="none" w="med" len="med"/>
+                      <a:tailEnd type="none" w="med" len="med"/>
+                    </a:lnB>
+                    <a:solidFill>
+                      <a:srgbClr val="FFFEFB"/>
+                    </a:solidFill>
+                  </a:tcPr>
+                </a:tc>
+                <a:tc>
+                  <a:txBody>
+                    <a:bodyPr/>
+                    <a:lstStyle/>
+                    <a:p>
+                      <a:pPr indent="0" marL="0">
+                        <a:lnSpc>
+                          <a:spcPts val="1820"/>
+                        </a:lnSpc>
+                        <a:buNone/>
+                      </a:pPr>
+                      <a:r>
+                        <a:rPr lang="en-US" sz="1300" dirty="0">
+                          <a:solidFill>
+                            <a:srgbClr val="3E4A57"/>
+                          </a:solidFill>
+                          <a:latin typeface="IBM Plex Sans KR" pitchFamily="34" charset="0"/>
+                          <a:ea typeface="IBM Plex Sans KR" pitchFamily="34" charset="-122"/>
+                          <a:cs typeface="IBM Plex Sans KR" pitchFamily="34" charset="-120"/>
+                        </a:rPr>
+                        <a:t>2차 성공이 LLM 없이 기록 경로만 재생해도 나오는지 확인하지 않음</a:t>
+                      </a:r>
+                      <a:endParaRPr lang="en-US" sz="1300" dirty="0">
+                        <a:latin typeface="IBM Plex Sans KR" charset="0"/>
+                        <a:ea typeface="IBM Plex Sans KR" charset="0"/>
+                        <a:cs typeface="IBM Plex Sans KR" charset="0"/>
+                      </a:endParaRPr>
+                    </a:p>
+                  </a:txBody>
+                  <a:tcPr marL="57785" marR="57785" marT="57785" marB="57785" anchor="t">
+                    <a:lnL w="12700" cap="flat" cmpd="sng" algn="ctr">
+                      <a:solidFill>
+                        <a:srgbClr val="CBCBC8"/>
+                      </a:solidFill>
+                      <a:prstDash val="solid"/>
+                      <a:round/>
+                      <a:headEnd type="none" w="med" len="med"/>
+                      <a:tailEnd type="none" w="med" len="med"/>
+                    </a:lnL>
+                    <a:lnR w="12700" cap="flat" cmpd="sng" algn="ctr">
+                      <a:solidFill>
+                        <a:srgbClr val="CBCBC8"/>
+                      </a:solidFill>
+                      <a:prstDash val="solid"/>
+                      <a:round/>
+                      <a:headEnd type="none" w="med" len="med"/>
+                      <a:tailEnd type="none" w="med" len="med"/>
+                    </a:lnR>
+                    <a:lnT w="12700" cap="flat" cmpd="sng" algn="ctr">
+                      <a:solidFill>
+                        <a:srgbClr val="C4C4C0"/>
+                      </a:solidFill>
+                      <a:prstDash val="solid"/>
+                      <a:round/>
+                      <a:headEnd type="none" w="med" len="med"/>
+                      <a:tailEnd type="none" w="med" len="med"/>
+                    </a:lnT>
+                    <a:lnB w="12700" cap="flat" cmpd="sng" algn="ctr">
+                      <a:solidFill>
+                        <a:srgbClr val="CBCBC8"/>
+                      </a:solidFill>
+                      <a:prstDash val="solid"/>
+                      <a:round/>
+                      <a:headEnd type="none" w="med" len="med"/>
+                      <a:tailEnd type="none" w="med" len="med"/>
+                    </a:lnB>
+                    <a:solidFill>
+                      <a:srgbClr val="FFFEFB"/>
+                    </a:solidFill>
+                  </a:tcPr>
+                </a:tc>
+              </a:tr>
+              <a:tr h="359321">
+                <a:tc>
+                  <a:txBody>
+                    <a:bodyPr/>
+                    <a:lstStyle/>
+                    <a:p>
+                      <a:pPr indent="0" marL="0">
+                        <a:lnSpc>
+                          <a:spcPts val="1820"/>
+                        </a:lnSpc>
+                        <a:buNone/>
+                      </a:pPr>
+                      <a:r>
+                        <a:rPr lang="en-US" sz="1300" dirty="0">
+                          <a:solidFill>
+                            <a:srgbClr val="3E4A57"/>
+                          </a:solidFill>
+                          <a:latin typeface="IBM Plex Sans KR" pitchFamily="34" charset="0"/>
+                          <a:ea typeface="IBM Plex Sans KR" pitchFamily="34" charset="-122"/>
+                          <a:cs typeface="IBM Plex Sans KR" pitchFamily="34" charset="-120"/>
+                        </a:rPr>
                         <a:t>실패 기록만의 조립체별 SKILL.md</a:t>
                       </a:r>
                       <a:endParaRPr lang="en-US" sz="1300" dirty="0">
@@ -9717,7 +11427,7 @@
                     </a:lnL>
                     <a:lnR w="12700" cap="flat" cmpd="sng" algn="ctr">
                       <a:solidFill>
-                        <a:srgbClr val="CBCBC8"/>
+                        <a:srgbClr val="C4C4C0"/>
                       </a:solidFill>
                       <a:prstDash val="solid"/>
                       <a:round/>
@@ -9726,7 +11436,7 @@
                     </a:lnR>
                     <a:lnT w="12700" cap="flat" cmpd="sng" algn="ctr">
                       <a:solidFill>
-                        <a:srgbClr val="C4C4C0"/>
+                        <a:srgbClr val="CBCBC8"/>
                       </a:solidFill>
                       <a:prstDash val="solid"/>
                       <a:round/>
@@ -9735,16 +11445,13 @@
                     </a:lnT>
                     <a:lnB w="12700" cap="flat" cmpd="sng" algn="ctr">
                       <a:solidFill>
-                        <a:srgbClr val="CBCBC8"/>
+                        <a:srgbClr val="C4C4C0"/>
                       </a:solidFill>
                       <a:prstDash val="solid"/>
                       <a:round/>
                       <a:headEnd type="none" w="med" len="med"/>
                       <a:tailEnd type="none" w="med" len="med"/>
                     </a:lnB>
-                    <a:solidFill>
-                      <a:srgbClr val="FFFEFB"/>
-                    </a:solidFill>
                   </a:tcPr>
                 </a:tc>
                 <a:tc>
@@ -9779,7 +11486,7 @@
                   <a:tcPr marL="57785" marR="57785" marT="57785" marB="57785" anchor="t">
                     <a:lnL w="12700" cap="flat" cmpd="sng" algn="ctr">
                       <a:solidFill>
-                        <a:srgbClr val="CBCBC8"/>
+                        <a:srgbClr val="C4C4C0"/>
                       </a:solidFill>
                       <a:prstDash val="solid"/>
                       <a:round/>
@@ -9788,7 +11495,7 @@
                     </a:lnL>
                     <a:lnR w="12700" cap="flat" cmpd="sng" algn="ctr">
                       <a:solidFill>
-                        <a:srgbClr val="CBCBC8"/>
+                        <a:srgbClr val="C4C4C0"/>
                       </a:solidFill>
                       <a:prstDash val="solid"/>
                       <a:round/>
@@ -9797,7 +11504,7 @@
                     </a:lnR>
                     <a:lnT w="12700" cap="flat" cmpd="sng" algn="ctr">
                       <a:solidFill>
-                        <a:srgbClr val="C4C4C0"/>
+                        <a:srgbClr val="CBCBC8"/>
                       </a:solidFill>
                       <a:prstDash val="solid"/>
                       <a:round/>
@@ -9806,16 +11513,13 @@
                     </a:lnT>
                     <a:lnB w="12700" cap="flat" cmpd="sng" algn="ctr">
                       <a:solidFill>
-                        <a:srgbClr val="CBCBC8"/>
+                        <a:srgbClr val="C4C4C0"/>
                       </a:solidFill>
                       <a:prstDash val="solid"/>
                       <a:round/>
                       <a:headEnd type="none" w="med" len="med"/>
                       <a:tailEnd type="none" w="med" len="med"/>
                     </a:lnB>
-                    <a:solidFill>
-                      <a:srgbClr val="FFFEFB"/>
-                    </a:solidFill>
                   </a:tcPr>
                 </a:tc>
               </a:tr>
@@ -9861,7 +11565,7 @@
                     </a:lnL>
                     <a:lnR w="12700" cap="flat" cmpd="sng" algn="ctr">
                       <a:solidFill>
-                        <a:srgbClr val="C4C4C0"/>
+                        <a:srgbClr val="CBCBC8"/>
                       </a:solidFill>
                       <a:prstDash val="solid"/>
                       <a:round/>
@@ -9870,7 +11574,7 @@
                     </a:lnR>
                     <a:lnT w="12700" cap="flat" cmpd="sng" algn="ctr">
                       <a:solidFill>
-                        <a:srgbClr val="CBCBC8"/>
+                        <a:srgbClr val="C4C4C0"/>
                       </a:solidFill>
                       <a:prstDash val="solid"/>
                       <a:round/>
@@ -9879,13 +11583,16 @@
                     </a:lnT>
                     <a:lnB w="12700" cap="flat" cmpd="sng" algn="ctr">
                       <a:solidFill>
-                        <a:srgbClr val="C4C4C0"/>
+                        <a:srgbClr val="CBCBC8"/>
                       </a:solidFill>
                       <a:prstDash val="solid"/>
                       <a:round/>
                       <a:headEnd type="none" w="med" len="med"/>
                       <a:tailEnd type="none" w="med" len="med"/>
                     </a:lnB>
+                    <a:solidFill>
+                      <a:srgbClr val="FFFEFB"/>
+                    </a:solidFill>
                   </a:tcPr>
                 </a:tc>
                 <a:tc>
@@ -9920,7 +11627,7 @@
                   <a:tcPr marL="57785" marR="57785" marT="57785" marB="57785" anchor="t">
                     <a:lnL w="12700" cap="flat" cmpd="sng" algn="ctr">
                       <a:solidFill>
-                        <a:srgbClr val="C4C4C0"/>
+                        <a:srgbClr val="CBCBC8"/>
                       </a:solidFill>
                       <a:prstDash val="solid"/>
                       <a:round/>
@@ -9929,7 +11636,7 @@
                     </a:lnL>
                     <a:lnR w="12700" cap="flat" cmpd="sng" algn="ctr">
                       <a:solidFill>
-                        <a:srgbClr val="C4C4C0"/>
+                        <a:srgbClr val="CBCBC8"/>
                       </a:solidFill>
                       <a:prstDash val="solid"/>
                       <a:round/>
@@ -9938,7 +11645,7 @@
                     </a:lnR>
                     <a:lnT w="12700" cap="flat" cmpd="sng" algn="ctr">
                       <a:solidFill>
-                        <a:srgbClr val="CBCBC8"/>
+                        <a:srgbClr val="C4C4C0"/>
                       </a:solidFill>
                       <a:prstDash val="solid"/>
                       <a:round/>
@@ -9947,13 +11654,16 @@
                     </a:lnT>
                     <a:lnB w="12700" cap="flat" cmpd="sng" algn="ctr">
                       <a:solidFill>
-                        <a:srgbClr val="C4C4C0"/>
+                        <a:srgbClr val="CBCBC8"/>
                       </a:solidFill>
                       <a:prstDash val="solid"/>
                       <a:round/>
                       <a:headEnd type="none" w="med" len="med"/>
                       <a:tailEnd type="none" w="med" len="med"/>
                     </a:lnB>
+                    <a:solidFill>
+                      <a:srgbClr val="FFFEFB"/>
+                    </a:solidFill>
                   </a:tcPr>
                 </a:tc>
               </a:tr>
@@ -9999,7 +11709,7 @@
                     </a:lnL>
                     <a:lnR w="12700" cap="flat" cmpd="sng" algn="ctr">
                       <a:solidFill>
-                        <a:srgbClr val="CBCBC8"/>
+                        <a:srgbClr val="C4C4C0"/>
                       </a:solidFill>
                       <a:prstDash val="solid"/>
                       <a:round/>
@@ -10008,7 +11718,7 @@
                     </a:lnR>
                     <a:lnT w="12700" cap="flat" cmpd="sng" algn="ctr">
                       <a:solidFill>
-                        <a:srgbClr val="C4C4C0"/>
+                        <a:srgbClr val="CBCBC8"/>
                       </a:solidFill>
                       <a:prstDash val="solid"/>
                       <a:round/>
@@ -10017,16 +11727,13 @@
                     </a:lnT>
                     <a:lnB w="12700" cap="flat" cmpd="sng" algn="ctr">
                       <a:solidFill>
-                        <a:srgbClr val="CBCBC8"/>
+                        <a:srgbClr val="C4C4C0"/>
                       </a:solidFill>
                       <a:prstDash val="solid"/>
                       <a:round/>
                       <a:headEnd type="none" w="med" len="med"/>
                       <a:tailEnd type="none" w="med" len="med"/>
                     </a:lnB>
-                    <a:solidFill>
-                      <a:srgbClr val="FFFEFB"/>
-                    </a:solidFill>
                   </a:tcPr>
                 </a:tc>
                 <a:tc>
@@ -10061,7 +11768,7 @@
                   <a:tcPr marL="57785" marR="57785" marT="57785" marB="57785" anchor="t">
                     <a:lnL w="12700" cap="flat" cmpd="sng" algn="ctr">
                       <a:solidFill>
-                        <a:srgbClr val="CBCBC8"/>
+                        <a:srgbClr val="C4C4C0"/>
                       </a:solidFill>
                       <a:prstDash val="solid"/>
                       <a:round/>
@@ -10070,7 +11777,7 @@
                     </a:lnL>
                     <a:lnR w="12700" cap="flat" cmpd="sng" algn="ctr">
                       <a:solidFill>
-                        <a:srgbClr val="CBCBC8"/>
+                        <a:srgbClr val="C4C4C0"/>
                       </a:solidFill>
                       <a:prstDash val="solid"/>
                       <a:round/>
@@ -10079,7 +11786,7 @@
                     </a:lnR>
                     <a:lnT w="12700" cap="flat" cmpd="sng" algn="ctr">
                       <a:solidFill>
-                        <a:srgbClr val="C4C4C0"/>
+                        <a:srgbClr val="CBCBC8"/>
                       </a:solidFill>
                       <a:prstDash val="solid"/>
                       <a:round/>
@@ -10088,16 +11795,13 @@
                     </a:lnT>
                     <a:lnB w="12700" cap="flat" cmpd="sng" algn="ctr">
                       <a:solidFill>
-                        <a:srgbClr val="CBCBC8"/>
+                        <a:srgbClr val="C4C4C0"/>
                       </a:solidFill>
                       <a:prstDash val="solid"/>
                       <a:round/>
                       <a:headEnd type="none" w="med" len="med"/>
                       <a:tailEnd type="none" w="med" len="med"/>
                     </a:lnB>
-                    <a:solidFill>
-                      <a:srgbClr val="FFFEFB"/>
-                    </a:solidFill>
                   </a:tcPr>
                 </a:tc>
               </a:tr>
@@ -10143,7 +11847,7 @@
                     </a:lnL>
                     <a:lnR w="12700" cap="flat" cmpd="sng" algn="ctr">
                       <a:solidFill>
-                        <a:srgbClr val="C4C4C0"/>
+                        <a:srgbClr val="CBCBC8"/>
                       </a:solidFill>
                       <a:prstDash val="solid"/>
                       <a:round/>
@@ -10152,7 +11856,7 @@
                     </a:lnR>
                     <a:lnT w="12700" cap="flat" cmpd="sng" algn="ctr">
                       <a:solidFill>
-                        <a:srgbClr val="CBCBC8"/>
+                        <a:srgbClr val="C4C4C0"/>
                       </a:solidFill>
                       <a:prstDash val="solid"/>
                       <a:round/>
@@ -10161,13 +11865,16 @@
                     </a:lnT>
                     <a:lnB w="12700" cap="flat" cmpd="sng" algn="ctr">
                       <a:solidFill>
-                        <a:srgbClr val="C4C4C0"/>
+                        <a:srgbClr val="CBCBC8"/>
                       </a:solidFill>
                       <a:prstDash val="solid"/>
                       <a:round/>
                       <a:headEnd type="none" w="med" len="med"/>
                       <a:tailEnd type="none" w="med" len="med"/>
                     </a:lnB>
+                    <a:solidFill>
+                      <a:srgbClr val="FFFEFB"/>
+                    </a:solidFill>
                   </a:tcPr>
                 </a:tc>
                 <a:tc>
@@ -10202,7 +11909,7 @@
                   <a:tcPr marL="57785" marR="57785" marT="57785" marB="57785" anchor="t">
                     <a:lnL w="12700" cap="flat" cmpd="sng" algn="ctr">
                       <a:solidFill>
-                        <a:srgbClr val="C4C4C0"/>
+                        <a:srgbClr val="CBCBC8"/>
                       </a:solidFill>
                       <a:prstDash val="solid"/>
                       <a:round/>
@@ -10211,7 +11918,7 @@
                     </a:lnL>
                     <a:lnR w="12700" cap="flat" cmpd="sng" algn="ctr">
                       <a:solidFill>
-                        <a:srgbClr val="C4C4C0"/>
+                        <a:srgbClr val="CBCBC8"/>
                       </a:solidFill>
                       <a:prstDash val="solid"/>
                       <a:round/>
@@ -10220,7 +11927,7 @@
                     </a:lnR>
                     <a:lnT w="12700" cap="flat" cmpd="sng" algn="ctr">
                       <a:solidFill>
-                        <a:srgbClr val="CBCBC8"/>
+                        <a:srgbClr val="C4C4C0"/>
                       </a:solidFill>
                       <a:prstDash val="solid"/>
                       <a:round/>
@@ -10229,13 +11936,16 @@
                     </a:lnT>
                     <a:lnB w="12700" cap="flat" cmpd="sng" algn="ctr">
                       <a:solidFill>
-                        <a:srgbClr val="C4C4C0"/>
+                        <a:srgbClr val="CBCBC8"/>
                       </a:solidFill>
                       <a:prstDash val="solid"/>
                       <a:round/>
                       <a:headEnd type="none" w="med" len="med"/>
                       <a:tailEnd type="none" w="med" len="med"/>
                     </a:lnB>
+                    <a:solidFill>
+                      <a:srgbClr val="FFFEFB"/>
+                    </a:solidFill>
                   </a:tcPr>
                 </a:tc>
               </a:tr>
@@ -10403,7 +12113,7 @@
                 <a:ea typeface="IBM Plex Sans KR" pitchFamily="34" charset="-122"/>
                 <a:cs typeface="IBM Plex Sans KR" pitchFamily="34" charset="-120"/>
               </a:rPr>
-              <a:t>더 약한 LLM 설정에서도, 조립체별 SKILL.md가 있으면 같은 조립체는 최소 시도로 분해할 수 있었다</a:t>
+              <a:t>gpt-6-luna(low) 설정에서, 조립체별 SKILL.md에 기록된 순서로 같은 조립체는 최소 시도로 분해할 수 있었다</a:t>
             </a:r>
             <a:endParaRPr lang="en-US" sz="3200" dirty="0"/>
           </a:p>
@@ -12286,7 +13996,7 @@
                 <a:ea typeface="IBM Plex Sans KR" pitchFamily="34" charset="-122"/>
                 <a:cs typeface="IBM Plex Sans KR" pitchFamily="34" charset="-120"/>
               </a:rPr>
-              <a:t>SKILL.md 기반 Disassembly Planner · 3 · 이 발표는 위 세 용어만 사용합니다</a:t>
+              <a:t>SKILL.md 기반 Disassembly Planner · 3 · S3·S5는 범용 SKILL.md의 버전 이름</a:t>
             </a:r>
             <a:endParaRPr lang="en-US" sz="1200" dirty="0"/>
           </a:p>
@@ -12947,11 +14657,11 @@
         <p:spPr>
           <a:xfrm>
             <a:off x="5997575" y="1826816"/>
-            <a:ext cx="5378450" cy="908645"/>
+            <a:ext cx="5378450" cy="2442170"/>
           </a:xfrm>
           <a:prstGeom prst="roundRect">
             <a:avLst>
-              <a:gd name="adj" fmla="val 13627"/>
+              <a:gd name="adj" fmla="val 5070"/>
             </a:avLst>
           </a:prstGeom>
           <a:solidFill>
@@ -12965,16 +14675,105 @@
           </a:ln>
         </p:spPr>
       </p:sp>
-      <p:sp>
-        <p:nvSpPr>
-          <p:cNvPr id="20" name="Text 15"/>
-          <p:cNvSpPr/>
+      <p:pic>
+        <p:nvPicPr>
+          <p:cNvPr id="20" name="Image 3" descr="평가 CAD 02260을 시뮬레이션 시작 상태로 렌더링한 그림">    </p:cNvPr>
+          <p:cNvPicPr>
+            <a:picLocks noChangeAspect="1"/>
+          </p:cNvPicPr>
           <p:nvPr/>
-        </p:nvSpPr>
-        <p:spPr>
-          <a:xfrm>
-            <a:off x="6229350" y="2007791"/>
-            <a:ext cx="5062347" cy="269230"/>
+        </p:nvPicPr>
+        <p:blipFill>
+          <a:blip r:embed="rId4"/>
+          <a:srcRect l="-27" r="-27" t="0" b="0"/>
+          <a:stretch/>
+        </p:blipFill>
+        <p:spPr>
+          <a:xfrm>
+            <a:off x="7213600" y="1956991"/>
+            <a:ext cx="2946400" cy="1905000"/>
+          </a:xfrm>
+          <a:prstGeom prst="rect">
+            <a:avLst/>
+          </a:prstGeom>
+        </p:spPr>
+      </p:pic>
+      <p:sp>
+        <p:nvSpPr>
+          <p:cNvPr id="21" name="Text 15"/>
+          <p:cNvSpPr/>
+          <p:nvPr/>
+        </p:nvSpPr>
+        <p:spPr>
+          <a:xfrm>
+            <a:off x="6000750" y="3925491"/>
+            <a:ext cx="5372050" cy="238720"/>
+          </a:xfrm>
+          <a:prstGeom prst="rect">
+            <a:avLst/>
+          </a:prstGeom>
+          <a:noFill/>
+          <a:ln/>
+        </p:spPr>
+        <p:txBody>
+          <a:bodyPr wrap="square" lIns="0" tIns="0" rIns="0" bIns="0" rtlCol="0" anchor="t">
+            <a:normAutofit/>
+          </a:bodyPr>
+          <a:lstStyle/>
+          <a:p>
+            <a:pPr algn="ctr" indent="0" marL="0">
+              <a:lnSpc>
+                <a:spcPts val="1680"/>
+              </a:lnSpc>
+              <a:buNone/>
+            </a:pPr>
+            <a:r>
+              <a:rPr lang="en-US" sz="1200" dirty="0">
+                <a:solidFill>
+                  <a:srgbClr val="4A5560"/>
+                </a:solidFill>
+                <a:latin typeface="IBM Plex Sans KR" pitchFamily="34" charset="0"/>
+                <a:ea typeface="IBM Plex Sans KR" pitchFamily="34" charset="-122"/>
+                <a:cs typeface="IBM Plex Sans KR" pitchFamily="34" charset="-120"/>
+              </a:rPr>
+              <a:t>평가 CAD 02260 · 부품 11개 중 1개 고정. 나머지 10개를 모두 빼면 성공</a:t>
+            </a:r>
+            <a:endParaRPr lang="en-US" sz="1200" dirty="0"/>
+          </a:p>
+        </p:txBody>
+      </p:sp>
+      <p:sp>
+        <p:nvSpPr>
+          <p:cNvPr id="22" name="Shape 16"/>
+          <p:cNvSpPr/>
+          <p:nvPr/>
+        </p:nvSpPr>
+        <p:spPr>
+          <a:xfrm>
+            <a:off x="5994400" y="4399161"/>
+            <a:ext cx="5384800" cy="1247080"/>
+          </a:xfrm>
+          <a:prstGeom prst="roundRect">
+            <a:avLst>
+              <a:gd name="adj" fmla="val 10184"/>
+            </a:avLst>
+          </a:prstGeom>
+          <a:solidFill>
+            <a:srgbClr val="F3E2CC"/>
+          </a:solidFill>
+          <a:ln/>
+        </p:spPr>
+      </p:sp>
+      <p:sp>
+        <p:nvSpPr>
+          <p:cNvPr id="23" name="Text 17"/>
+          <p:cNvSpPr/>
+          <p:nvPr/>
+        </p:nvSpPr>
+        <p:spPr>
+          <a:xfrm>
+            <a:off x="6197600" y="4551561"/>
+            <a:ext cx="5127752" cy="254000"/>
           </a:xfrm>
           <a:prstGeom prst="rect">
             <a:avLst/>
@@ -12990,127 +14789,12 @@
           <a:p>
             <a:pPr algn="l" indent="0" marL="0">
               <a:lnSpc>
-                <a:spcPts val="1920"/>
+                <a:spcPts val="1800"/>
               </a:lnSpc>
               <a:buNone/>
             </a:pPr>
             <a:r>
-              <a:rPr lang="en-US" sz="1600" b="1" dirty="0">
-                <a:solidFill>
-                  <a:srgbClr val="1C2430"/>
-                </a:solidFill>
-                <a:latin typeface="IBM Plex Sans KR" pitchFamily="34" charset="0"/>
-                <a:ea typeface="IBM Plex Sans KR" pitchFamily="34" charset="-122"/>
-                <a:cs typeface="IBM Plex Sans KR" pitchFamily="34" charset="-120"/>
-              </a:rPr>
-              <a:t>성공 조건</a:t>
-            </a:r>
-            <a:endParaRPr lang="en-US" sz="1600" dirty="0"/>
-          </a:p>
-        </p:txBody>
-      </p:sp>
-      <p:sp>
-        <p:nvSpPr>
-          <p:cNvPr id="21" name="Text 16"/>
-          <p:cNvSpPr/>
-          <p:nvPr/>
-        </p:nvSpPr>
-        <p:spPr>
-          <a:xfrm>
-            <a:off x="6229350" y="2315121"/>
-            <a:ext cx="5062347" cy="264765"/>
-          </a:xfrm>
-          <a:prstGeom prst="rect">
-            <a:avLst/>
-          </a:prstGeom>
-          <a:noFill/>
-          <a:ln/>
-        </p:spPr>
-        <p:txBody>
-          <a:bodyPr wrap="square" lIns="0" tIns="0" rIns="0" bIns="0" rtlCol="0" anchor="t">
-            <a:normAutofit/>
-          </a:bodyPr>
-          <a:lstStyle/>
-          <a:p>
-            <a:pPr algn="l" indent="0" marL="0">
-              <a:lnSpc>
-                <a:spcPts val="1885"/>
-              </a:lnSpc>
-              <a:buNone/>
-            </a:pPr>
-            <a:r>
-              <a:rPr lang="en-US" sz="1300" dirty="0">
-                <a:solidFill>
-                  <a:srgbClr val="4A5560"/>
-                </a:solidFill>
-                <a:latin typeface="IBM Plex Sans KR" pitchFamily="34" charset="0"/>
-                <a:ea typeface="IBM Plex Sans KR" pitchFamily="34" charset="-122"/>
-                <a:cs typeface="IBM Plex Sans KR" pitchFamily="34" charset="-120"/>
-              </a:rPr>
-              <a:t>고정 부품 하나만 남을 때까지 모든 부품을 제거</a:t>
-            </a:r>
-            <a:endParaRPr lang="en-US" sz="1300" dirty="0"/>
-          </a:p>
-        </p:txBody>
-      </p:sp>
-      <p:sp>
-        <p:nvSpPr>
-          <p:cNvPr id="22" name="Shape 17"/>
-          <p:cNvSpPr/>
-          <p:nvPr/>
-        </p:nvSpPr>
-        <p:spPr>
-          <a:xfrm>
-            <a:off x="5997575" y="2894211"/>
-            <a:ext cx="5378450" cy="1148011"/>
-          </a:xfrm>
-          <a:prstGeom prst="roundRect">
-            <a:avLst>
-              <a:gd name="adj" fmla="val 10786"/>
-            </a:avLst>
-          </a:prstGeom>
-          <a:solidFill>
-            <a:srgbClr val="FFFEFB"/>
-          </a:solidFill>
-          <a:ln w="6350">
-            <a:solidFill>
-              <a:srgbClr val="DCD8CF"/>
-            </a:solidFill>
-            <a:prstDash val="solid"/>
-          </a:ln>
-        </p:spPr>
-      </p:sp>
-      <p:sp>
-        <p:nvSpPr>
-          <p:cNvPr id="23" name="Text 18"/>
-          <p:cNvSpPr/>
-          <p:nvPr/>
-        </p:nvSpPr>
-        <p:spPr>
-          <a:xfrm>
-            <a:off x="6229350" y="3075186"/>
-            <a:ext cx="5062347" cy="269230"/>
-          </a:xfrm>
-          <a:prstGeom prst="rect">
-            <a:avLst/>
-          </a:prstGeom>
-          <a:noFill/>
-          <a:ln/>
-        </p:spPr>
-        <p:txBody>
-          <a:bodyPr wrap="square" lIns="0" tIns="0" rIns="0" bIns="0" rtlCol="0" anchor="t">
-            <a:normAutofit/>
-          </a:bodyPr>
-          <a:lstStyle/>
-          <a:p>
-            <a:pPr algn="l" indent="0" marL="0">
-              <a:lnSpc>
-                <a:spcPts val="1920"/>
-              </a:lnSpc>
-              <a:buNone/>
-            </a:pPr>
-            <a:r>
-              <a:rPr lang="en-US" sz="1600" b="1" dirty="0">
+              <a:rPr lang="en-US" sz="1500" b="1" dirty="0">
                 <a:solidFill>
                   <a:srgbClr val="1C2430"/>
                 </a:solidFill>
@@ -13120,20 +14804,20 @@
               </a:rPr>
               <a:t>어려운 이유</a:t>
             </a:r>
-            <a:endParaRPr lang="en-US" sz="1600" dirty="0"/>
+            <a:endParaRPr lang="en-US" sz="1500" dirty="0"/>
           </a:p>
         </p:txBody>
       </p:sp>
       <p:sp>
         <p:nvSpPr>
-          <p:cNvPr id="24" name="Text 19"/>
+          <p:cNvPr id="24" name="Text 18"/>
           <p:cNvSpPr/>
           <p:nvPr/>
         </p:nvSpPr>
         <p:spPr>
           <a:xfrm>
-            <a:off x="6229350" y="3382516"/>
-            <a:ext cx="5062347" cy="504130"/>
+            <a:off x="6197600" y="4830961"/>
+            <a:ext cx="5127752" cy="688280"/>
           </a:xfrm>
           <a:prstGeom prst="rect">
             <a:avLst/>
@@ -13149,122 +14833,12 @@
           <a:p>
             <a:pPr algn="l" indent="0" marL="0">
               <a:lnSpc>
-                <a:spcPts val="1885"/>
+                <a:spcPts val="1740"/>
               </a:lnSpc>
               <a:buNone/>
             </a:pPr>
             <a:r>
-              <a:rPr lang="en-US" sz="1300" dirty="0">
-                <a:solidFill>
-                  <a:srgbClr val="4A5560"/>
-                </a:solidFill>
-                <a:latin typeface="IBM Plex Sans KR" pitchFamily="34" charset="0"/>
-                <a:ea typeface="IBM Plex Sans KR" pitchFamily="34" charset="-122"/>
-                <a:cs typeface="IBM Plex Sans KR" pitchFamily="34" charset="-120"/>
-              </a:rPr>
-              <a:t>막힘이 상태에 따라 바뀝니다. 지금 못 빼는 부품도 다른 부품이 빠지면 빠질 수 있고, 순서를 잘못 고르면 남은 구조가 무너집니다.</a:t>
-            </a:r>
-            <a:endParaRPr lang="en-US" sz="1300" dirty="0"/>
-          </a:p>
-        </p:txBody>
-      </p:sp>
-      <p:sp>
-        <p:nvSpPr>
-          <p:cNvPr id="25" name="Shape 20"/>
-          <p:cNvSpPr/>
-          <p:nvPr/>
-        </p:nvSpPr>
-        <p:spPr>
-          <a:xfrm>
-            <a:off x="5994400" y="4197796"/>
-            <a:ext cx="5384800" cy="1141661"/>
-          </a:xfrm>
-          <a:prstGeom prst="roundRect">
-            <a:avLst>
-              <a:gd name="adj" fmla="val 11124"/>
-            </a:avLst>
-          </a:prstGeom>
-          <a:solidFill>
-            <a:srgbClr val="F3E2CC"/>
-          </a:solidFill>
-          <a:ln/>
-        </p:spPr>
-      </p:sp>
-      <p:sp>
-        <p:nvSpPr>
-          <p:cNvPr id="26" name="Text 21"/>
-          <p:cNvSpPr/>
-          <p:nvPr/>
-        </p:nvSpPr>
-        <p:spPr>
-          <a:xfrm>
-            <a:off x="6223000" y="4375596"/>
-            <a:ext cx="5075428" cy="269230"/>
-          </a:xfrm>
-          <a:prstGeom prst="rect">
-            <a:avLst/>
-          </a:prstGeom>
-          <a:noFill/>
-          <a:ln/>
-        </p:spPr>
-        <p:txBody>
-          <a:bodyPr wrap="square" lIns="0" tIns="0" rIns="0" bIns="0" rtlCol="0" anchor="t">
-            <a:normAutofit/>
-          </a:bodyPr>
-          <a:lstStyle/>
-          <a:p>
-            <a:pPr algn="l" indent="0" marL="0">
-              <a:lnSpc>
-                <a:spcPts val="1920"/>
-              </a:lnSpc>
-              <a:buNone/>
-            </a:pPr>
-            <a:r>
-              <a:rPr lang="en-US" sz="1600" b="1" dirty="0">
-                <a:solidFill>
-                  <a:srgbClr val="1C2430"/>
-                </a:solidFill>
-                <a:latin typeface="IBM Plex Sans KR" pitchFamily="34" charset="0"/>
-                <a:ea typeface="IBM Plex Sans KR" pitchFamily="34" charset="-122"/>
-                <a:cs typeface="IBM Plex Sans KR" pitchFamily="34" charset="-120"/>
-              </a:rPr>
-              <a:t>검사는 비싸다</a:t>
-            </a:r>
-            <a:endParaRPr lang="en-US" sz="1600" dirty="0"/>
-          </a:p>
-        </p:txBody>
-      </p:sp>
-      <p:sp>
-        <p:nvSpPr>
-          <p:cNvPr id="27" name="Text 22"/>
-          <p:cNvSpPr/>
-          <p:nvPr/>
-        </p:nvSpPr>
-        <p:spPr>
-          <a:xfrm>
-            <a:off x="6223000" y="4682927"/>
-            <a:ext cx="5075428" cy="504130"/>
-          </a:xfrm>
-          <a:prstGeom prst="rect">
-            <a:avLst/>
-          </a:prstGeom>
-          <a:noFill/>
-          <a:ln/>
-        </p:spPr>
-        <p:txBody>
-          <a:bodyPr wrap="square" lIns="0" tIns="0" rIns="0" bIns="0" rtlCol="0" anchor="t">
-            <a:normAutofit/>
-          </a:bodyPr>
-          <a:lstStyle/>
-          <a:p>
-            <a:pPr algn="l" indent="0" marL="0">
-              <a:lnSpc>
-                <a:spcPts val="1885"/>
-              </a:lnSpc>
-              <a:buNone/>
-            </a:pPr>
-            <a:r>
-              <a:rPr lang="en-US" sz="1300" dirty="0">
+              <a:rPr lang="en-US" sz="1200" dirty="0">
                 <a:solidFill>
                   <a:srgbClr val="3E4A57"/>
                 </a:solidFill>
@@ -13272,15 +14846,15 @@
                 <a:ea typeface="IBM Plex Sans KR" pitchFamily="34" charset="-122"/>
                 <a:cs typeface="IBM Plex Sans KR" pitchFamily="34" charset="-120"/>
               </a:rPr>
-              <a:t>충돌 거절 중앙값 2.1초, 불안정 판정 19.6초. 에피소드당 검사 240회, 900초 안에 끝내야 합니다.</a:t>
+              <a:t>막힘이 상태에 따라 바뀌고, 순서를 잘못 고르면 남은 구조가 무너집니다. 검사도 비쌉니다: 충돌 거절 중앙값 2.1초, 불안정 판정 19.6초, 에피소드당 검사 240회·900초</a:t>
             </a:r>
-            <a:endParaRPr lang="en-US" sz="1300" dirty="0"/>
+            <a:endParaRPr lang="en-US" sz="1200" dirty="0"/>
           </a:p>
         </p:txBody>
       </p:sp>
       <p:sp>
         <p:nvSpPr>
-          <p:cNvPr id="28" name="Text 23"/>
+          <p:cNvPr id="25" name="Text 19"/>
           <p:cNvSpPr/>
           <p:nvPr/>
         </p:nvSpPr>
@@ -14323,7 +15897,7 @@
                 <a:ea typeface="IBM Plex Sans KR" pitchFamily="34" charset="-122"/>
                 <a:cs typeface="IBM Plex Sans KR" pitchFamily="34" charset="-120"/>
               </a:rPr>
-              <a:t> 같은 모델(gpt-6-luna, low) · 같은 API · 같은 예산(호출 8, 검사 240, 900초) → 차이는 SKILL.md 유무와 역할 분담에서만 나옵니다</a:t>
+              <a:t> 같은 모델(gpt-6-luna, low) · 같은 API · 같은 예산(호출 8, 검사 240, 900초) → 설계상 다른 점은 SKILL.md 유무와 역할 분담뿐입니다</a:t>
             </a:r>
             <a:endParaRPr lang="en-US" sz="1200" dirty="0"/>
           </a:p>
@@ -18533,7 +20107,7 @@
                 <a:ea typeface="IBM Plex Sans KR" pitchFamily="34" charset="-122"/>
                 <a:cs typeface="IBM Plex Sans KR" pitchFamily="34" charset="-120"/>
               </a:rPr>
-              <a:t>S5는 개발 검증에서 불승인 → 사전 규칙상 주 분석은 S3. 이 발표는 최신 S5 기준으로 보이고 S3를 함께 표시</a:t>
+              <a:t>최신은 S5지만 개발 검증 불승인 → 실행 전 규칙상 주 분석은 S3. 두 버전 모두 같은 새 CAD 4개에서 실행</a:t>
             </a:r>
             <a:endParaRPr lang="en-US" sz="1200" dirty="0"/>
           </a:p>
@@ -18699,7 +20273,7 @@
                 <a:ea typeface="IBM Plex Sans KR" pitchFamily="34" charset="-122"/>
                 <a:cs typeface="IBM Plex Sans KR" pitchFamily="34" charset="-120"/>
               </a:rPr>
-              <a:t>조립체별 SKILL.md를 쓴 2차 시도는 모두 성공했다</a:t>
+              <a:t>기록된 순서를 다시 쓰자 2차 시도는 모두 성공했다</a:t>
             </a:r>
             <a:endParaRPr lang="en-US" sz="3200" dirty="0"/>
           </a:p>
@@ -21206,6 +22780,17 @@
               <a:buNone/>
             </a:pPr>
             <a:r>
+              <a:rPr lang="en-US" sz="1200" b="1" dirty="0">
+                <a:solidFill>
+                  <a:srgbClr val="3E4A57"/>
+                </a:solidFill>
+                <a:latin typeface="IBM Plex Sans KR" pitchFamily="34" charset="0"/>
+                <a:ea typeface="IBM Plex Sans KR" pitchFamily="34" charset="-122"/>
+                <a:cs typeface="IBM Plex Sans KR" pitchFamily="34" charset="-120"/>
+              </a:rPr>
+              <a:t>해석</a:t>
+            </a:r>
+            <a:r>
               <a:rPr lang="en-US" sz="1200" dirty="0">
                 <a:solidFill>
                   <a:srgbClr val="3E4A57"/>
@@ -21214,7 +22799,7 @@
                 <a:ea typeface="IBM Plex Sans KR" pitchFamily="34" charset="-122"/>
                 <a:cs typeface="IBM Plex Sans KR" pitchFamily="34" charset="-120"/>
               </a:rPr>
-              <a:t>가장 느린 02260: 조립체별 SKILL.md를 쓴 6회는 모두 검사 10회, 416~441초. 없으면 A와 C·S3가 900초 안에 끝내지 못함</a:t>
+              <a:t> 주된 원인은 1차에서 검증된 제거 순서를 기록해 다시 쓴 것입니다(경로만 재생하는 대조는 하지 않음). 의미는 반복 제품에서의 신뢰성과 실패 시도 감소에 있습니다.</a:t>
             </a:r>
             <a:endParaRPr lang="en-US" sz="1200" dirty="0"/>
           </a:p>
@@ -21295,10 +22880,10 @@
         <a:srgbClr val="E9A54A"/>
       </a:accent2>
       <a:accent3>
-        <a:srgbClr val="F3E2CC"/>
+        <a:srgbClr val="2F6E9A"/>
       </a:accent3>
       <a:accent4>
-        <a:srgbClr val="2F6E9A"/>
+        <a:srgbClr val="F3E2CC"/>
       </a:accent4>
       <a:accent5>
         <a:srgbClr val="E0912F"/>

</xml_diff>